<commit_message>
Update Week 2 cover artwork
</commit_message>
<xml_diff>
--- a/week-02-input-ai-workflow/slides/week-02-build-test-improve.pptx
+++ b/week-02-input-ai-workflow/slides/week-02-build-test-improve.pptx
@@ -2,32 +2,32 @@
 <file path=ppt/presentation.xml><?xml version="1.0" encoding="utf-8"?>
 <p:presentation xmlns:p="http://schemas.openxmlformats.org/presentationml/2006/main">
   <p:sldMasterIdLst>
-    <p:sldMasterId xmlns:r="http://schemas.openxmlformats.org/officeDocument/2006/relationships" id="2147483648" r:id="R5bdd29d7cc134d7c"/>
+    <p:sldMasterId xmlns:r="http://schemas.openxmlformats.org/officeDocument/2006/relationships" id="2147483648" r:id="Ra513109788034461"/>
   </p:sldMasterIdLst>
   <p:notesMasterIdLst>
-    <p:notesMasterId xmlns:r="http://schemas.openxmlformats.org/officeDocument/2006/relationships" r:id="R7c2d35cf78204883"/>
+    <p:notesMasterId xmlns:r="http://schemas.openxmlformats.org/officeDocument/2006/relationships" r:id="R00b5b5cfde09495c"/>
   </p:notesMasterIdLst>
   <p:sldIdLst>
-    <p:sldId xmlns:r="http://schemas.openxmlformats.org/officeDocument/2006/relationships" id="256" r:id="R43f2531302db4216"/>
-    <p:sldId xmlns:r="http://schemas.openxmlformats.org/officeDocument/2006/relationships" id="257" r:id="R728e620e4d2e4e83"/>
-    <p:sldId xmlns:r="http://schemas.openxmlformats.org/officeDocument/2006/relationships" id="258" r:id="R7e7ba91aac4344ff"/>
-    <p:sldId xmlns:r="http://schemas.openxmlformats.org/officeDocument/2006/relationships" id="259" r:id="R5c5683f36ac5472a"/>
-    <p:sldId xmlns:r="http://schemas.openxmlformats.org/officeDocument/2006/relationships" id="260" r:id="R50d65b57fcf74a7f"/>
-    <p:sldId xmlns:r="http://schemas.openxmlformats.org/officeDocument/2006/relationships" id="261" r:id="R40520db29b6d4ff3"/>
-    <p:sldId xmlns:r="http://schemas.openxmlformats.org/officeDocument/2006/relationships" id="262" r:id="Re8a487ea11eb4e49"/>
-    <p:sldId xmlns:r="http://schemas.openxmlformats.org/officeDocument/2006/relationships" id="263" r:id="Rab7c7591bb9b499c"/>
-    <p:sldId xmlns:r="http://schemas.openxmlformats.org/officeDocument/2006/relationships" id="264" r:id="Rc0cef4b39e0f4b94"/>
-    <p:sldId xmlns:r="http://schemas.openxmlformats.org/officeDocument/2006/relationships" id="265" r:id="R0903eeb662a0429c"/>
-    <p:sldId xmlns:r="http://schemas.openxmlformats.org/officeDocument/2006/relationships" id="266" r:id="R8b620e26ce1d4646"/>
-    <p:sldId xmlns:r="http://schemas.openxmlformats.org/officeDocument/2006/relationships" id="267" r:id="Rfaf81f68f39f428f"/>
-    <p:sldId xmlns:r="http://schemas.openxmlformats.org/officeDocument/2006/relationships" id="268" r:id="R80cf467d62cc4fd1"/>
-    <p:sldId xmlns:r="http://schemas.openxmlformats.org/officeDocument/2006/relationships" id="269" r:id="R2691e8fa79604428"/>
-    <p:sldId xmlns:r="http://schemas.openxmlformats.org/officeDocument/2006/relationships" id="270" r:id="R90dcd597ee0c45f5"/>
-    <p:sldId xmlns:r="http://schemas.openxmlformats.org/officeDocument/2006/relationships" id="271" r:id="R3b3e3d065ba14e1d"/>
-    <p:sldId xmlns:r="http://schemas.openxmlformats.org/officeDocument/2006/relationships" id="272" r:id="R5bd58ead03f14d42"/>
-    <p:sldId xmlns:r="http://schemas.openxmlformats.org/officeDocument/2006/relationships" id="273" r:id="R4f897641f85046a2"/>
-    <p:sldId xmlns:r="http://schemas.openxmlformats.org/officeDocument/2006/relationships" id="274" r:id="Rabcd992cdebe4223"/>
-    <p:sldId xmlns:r="http://schemas.openxmlformats.org/officeDocument/2006/relationships" id="275" r:id="R16e3d4d5c27249f6"/>
+    <p:sldId xmlns:r="http://schemas.openxmlformats.org/officeDocument/2006/relationships" id="256" r:id="Rfba31051696d40b4"/>
+    <p:sldId xmlns:r="http://schemas.openxmlformats.org/officeDocument/2006/relationships" id="257" r:id="Reddbfeb3807a4ffe"/>
+    <p:sldId xmlns:r="http://schemas.openxmlformats.org/officeDocument/2006/relationships" id="258" r:id="R37cba18b81074b66"/>
+    <p:sldId xmlns:r="http://schemas.openxmlformats.org/officeDocument/2006/relationships" id="259" r:id="R0bdcfecdd80d4feb"/>
+    <p:sldId xmlns:r="http://schemas.openxmlformats.org/officeDocument/2006/relationships" id="260" r:id="Rfebd011b2dc44f49"/>
+    <p:sldId xmlns:r="http://schemas.openxmlformats.org/officeDocument/2006/relationships" id="261" r:id="Re73d9a879c224153"/>
+    <p:sldId xmlns:r="http://schemas.openxmlformats.org/officeDocument/2006/relationships" id="262" r:id="R4acf0e71b3d542a6"/>
+    <p:sldId xmlns:r="http://schemas.openxmlformats.org/officeDocument/2006/relationships" id="263" r:id="Rdfe1af97e52d4196"/>
+    <p:sldId xmlns:r="http://schemas.openxmlformats.org/officeDocument/2006/relationships" id="264" r:id="R5a46e082a084432e"/>
+    <p:sldId xmlns:r="http://schemas.openxmlformats.org/officeDocument/2006/relationships" id="265" r:id="R7bcf93bcf17048ea"/>
+    <p:sldId xmlns:r="http://schemas.openxmlformats.org/officeDocument/2006/relationships" id="266" r:id="Rd4db6b5f431c4a9b"/>
+    <p:sldId xmlns:r="http://schemas.openxmlformats.org/officeDocument/2006/relationships" id="267" r:id="Rc5cc452e792b4167"/>
+    <p:sldId xmlns:r="http://schemas.openxmlformats.org/officeDocument/2006/relationships" id="268" r:id="Rc492fe948710486f"/>
+    <p:sldId xmlns:r="http://schemas.openxmlformats.org/officeDocument/2006/relationships" id="269" r:id="R6bad549dbd374d0d"/>
+    <p:sldId xmlns:r="http://schemas.openxmlformats.org/officeDocument/2006/relationships" id="270" r:id="R5d4770bf2dae476b"/>
+    <p:sldId xmlns:r="http://schemas.openxmlformats.org/officeDocument/2006/relationships" id="271" r:id="Re9923287e2694438"/>
+    <p:sldId xmlns:r="http://schemas.openxmlformats.org/officeDocument/2006/relationships" id="272" r:id="Rbdf35feeea87401f"/>
+    <p:sldId xmlns:r="http://schemas.openxmlformats.org/officeDocument/2006/relationships" id="273" r:id="R9160abddc554433e"/>
+    <p:sldId xmlns:r="http://schemas.openxmlformats.org/officeDocument/2006/relationships" id="274" r:id="R49ab13501d6d49d4"/>
+    <p:sldId xmlns:r="http://schemas.openxmlformats.org/officeDocument/2006/relationships" id="275" r:id="Rd4b574ed3fb0452c"/>
   </p:sldIdLst>
   <p:sldSz cx="12192000" cy="6858000"/>
   <p:notesSz cx="6858000" cy="9144000"/>
@@ -461,7 +461,7 @@
           <a:lstStyle xmlns:a="http://schemas.openxmlformats.org/drawingml/2006/main"/>
           <a:p xmlns:a="http://schemas.openxmlformats.org/drawingml/2006/main">
             <a:r>
-              <a:t>Generated classroom illustration. It does not depict an actual Project Syncere class. Open with the joke that code working once does not mean the job is finished. Today students will build an app, test it, and let a classmate find the next improvement.</a:t>
+              <a:t>Generated abstract illustration. Open with the joke that code working once does not mean the job is finished. The strange pixel duck represents the wonderfully unpredictable things software can do. Today students will build an app, test it, and let a classmate find the next improvement.</a:t>
             </a:r>
           </a:p>
         </p:txBody>
@@ -1838,7 +1838,7 @@
           <p:cNvPr id="3" name="Title">
             <a:extLst xmlns:a="http://schemas.openxmlformats.org/drawingml/2006/main">
               <a:ext uri="{FF2B5EF4-FFF2-40B4-BE49-F238E27FC236}">
-                <a16:creationId xmlns:a16="http://schemas.microsoft.com/office/drawing/2014/main" id="{846C3EFD-AA59-480E-9B0D-FDF2FD8A95CE}"/>
+                <a16:creationId xmlns:a16="http://schemas.microsoft.com/office/drawing/2014/main" id="{E0C84E0E-EC05-40B6-81CC-60E33B7A00BD}"/>
               </a:ext>
             </a:extLst>
           </p:cNvPr>
@@ -1995,7 +1995,7 @@
           <p:cNvPr id="2" name="Subtitle">
             <a:extLst xmlns:a="http://schemas.openxmlformats.org/drawingml/2006/main">
               <a:ext uri="{FF2B5EF4-FFF2-40B4-BE49-F238E27FC236}">
-                <a16:creationId xmlns:a16="http://schemas.microsoft.com/office/drawing/2014/main" id="{5A8ED701-ADBD-44A6-B902-A4C44CEBC966}"/>
+                <a16:creationId xmlns:a16="http://schemas.microsoft.com/office/drawing/2014/main" id="{2E43B8EA-3520-4932-9C48-256887E35DDB}"/>
               </a:ext>
             </a:extLst>
           </p:cNvPr>
@@ -2169,7 +2169,7 @@
           <p:cNvPr id="2" name="Section title">
             <a:extLst xmlns:a="http://schemas.openxmlformats.org/drawingml/2006/main">
               <a:ext uri="{FF2B5EF4-FFF2-40B4-BE49-F238E27FC236}">
-                <a16:creationId xmlns:a16="http://schemas.microsoft.com/office/drawing/2014/main" id="{6D65E5ED-E3CC-4177-8981-F98A9589B76A}"/>
+                <a16:creationId xmlns:a16="http://schemas.microsoft.com/office/drawing/2014/main" id="{058DFA06-8C92-44DD-B1EA-7173F3CA7EE6}"/>
               </a:ext>
             </a:extLst>
           </p:cNvPr>
@@ -2343,7 +2343,7 @@
           <p:cNvPr id="3" name="Title">
             <a:extLst xmlns:a="http://schemas.openxmlformats.org/drawingml/2006/main">
               <a:ext uri="{FF2B5EF4-FFF2-40B4-BE49-F238E27FC236}">
-                <a16:creationId xmlns:a16="http://schemas.microsoft.com/office/drawing/2014/main" id="{C4B699FF-07CE-4E3C-92F8-236E85D1055C}"/>
+                <a16:creationId xmlns:a16="http://schemas.microsoft.com/office/drawing/2014/main" id="{F08E4C87-24B5-48AA-9A40-AF6A51872B9E}"/>
               </a:ext>
             </a:extLst>
           </p:cNvPr>
@@ -2500,7 +2500,7 @@
           <p:cNvPr id="2" name="Body">
             <a:extLst xmlns:a="http://schemas.openxmlformats.org/drawingml/2006/main">
               <a:ext uri="{FF2B5EF4-FFF2-40B4-BE49-F238E27FC236}">
-                <a16:creationId xmlns:a16="http://schemas.microsoft.com/office/drawing/2014/main" id="{5ACBDE84-E430-486C-B153-E6F56F8C5A0E}"/>
+                <a16:creationId xmlns:a16="http://schemas.microsoft.com/office/drawing/2014/main" id="{CBCDA751-B025-4E58-BF7C-9EE3243E3F23}"/>
               </a:ext>
             </a:extLst>
           </p:cNvPr>
@@ -2674,7 +2674,7 @@
           <p:cNvPr id="4" name="Title">
             <a:extLst xmlns:a="http://schemas.openxmlformats.org/drawingml/2006/main">
               <a:ext uri="{FF2B5EF4-FFF2-40B4-BE49-F238E27FC236}">
-                <a16:creationId xmlns:a16="http://schemas.microsoft.com/office/drawing/2014/main" id="{E2457DED-9A8A-4564-BF74-D6B63808809A}"/>
+                <a16:creationId xmlns:a16="http://schemas.microsoft.com/office/drawing/2014/main" id="{C290BE37-E880-4CC1-9210-D57C91C6A3D1}"/>
               </a:ext>
             </a:extLst>
           </p:cNvPr>
@@ -2831,7 +2831,7 @@
           <p:cNvPr id="2" name="Left column">
             <a:extLst xmlns:a="http://schemas.openxmlformats.org/drawingml/2006/main">
               <a:ext uri="{FF2B5EF4-FFF2-40B4-BE49-F238E27FC236}">
-                <a16:creationId xmlns:a16="http://schemas.microsoft.com/office/drawing/2014/main" id="{B6C815BA-F82C-4F56-BF53-A1566371B9A5}"/>
+                <a16:creationId xmlns:a16="http://schemas.microsoft.com/office/drawing/2014/main" id="{EF9C9BD8-DAA0-4C9F-8397-C73F9EDED024}"/>
               </a:ext>
             </a:extLst>
           </p:cNvPr>
@@ -2988,7 +2988,7 @@
           <p:cNvPr id="3" name="Right column">
             <a:extLst xmlns:a="http://schemas.openxmlformats.org/drawingml/2006/main">
               <a:ext uri="{FF2B5EF4-FFF2-40B4-BE49-F238E27FC236}">
-                <a16:creationId xmlns:a16="http://schemas.microsoft.com/office/drawing/2014/main" id="{8A6665F1-7166-461C-9F30-41F2DDCF003A}"/>
+                <a16:creationId xmlns:a16="http://schemas.microsoft.com/office/drawing/2014/main" id="{527FF19C-B794-4741-9DC0-0641368E1EE2}"/>
               </a:ext>
             </a:extLst>
           </p:cNvPr>
@@ -3162,7 +3162,7 @@
           <p:cNvPr id="3" name="Title">
             <a:extLst xmlns:a="http://schemas.openxmlformats.org/drawingml/2006/main">
               <a:ext uri="{FF2B5EF4-FFF2-40B4-BE49-F238E27FC236}">
-                <a16:creationId xmlns:a16="http://schemas.microsoft.com/office/drawing/2014/main" id="{207BD446-C431-4748-8B48-C3864BBBB5C5}"/>
+                <a16:creationId xmlns:a16="http://schemas.microsoft.com/office/drawing/2014/main" id="{9357B076-3842-466B-BD58-6A4EEEAF294A}"/>
               </a:ext>
             </a:extLst>
           </p:cNvPr>
@@ -3319,7 +3319,7 @@
           <p:cNvPr id="2" name="Left column">
             <a:extLst xmlns:a="http://schemas.openxmlformats.org/drawingml/2006/main">
               <a:ext uri="{FF2B5EF4-FFF2-40B4-BE49-F238E27FC236}">
-                <a16:creationId xmlns:a16="http://schemas.microsoft.com/office/drawing/2014/main" id="{C9633C29-6143-49DC-8EA2-65DFB687BB55}"/>
+                <a16:creationId xmlns:a16="http://schemas.microsoft.com/office/drawing/2014/main" id="{59D67D4A-2F9F-4646-95EF-FD7CD8B6F4B5}"/>
               </a:ext>
             </a:extLst>
           </p:cNvPr>
@@ -3514,12 +3514,12 @@
   </p:cSld>
   <p:clrMap bg1="lt1" tx1="dk1" bg2="lt2" tx2="dk2" accent1="accent1" accent2="accent2" accent3="accent3" accent4="accent4" accent5="accent5" accent6="accent6" hlink="hlink" folHlink="folHlink"/>
   <p:sldLayoutIdLst>
-    <p:sldLayoutId xmlns:r="http://schemas.openxmlformats.org/officeDocument/2006/relationships" id="2147483649" r:id="R2c9d0feac27e44ce"/>
-    <p:sldLayoutId xmlns:r="http://schemas.openxmlformats.org/officeDocument/2006/relationships" id="2147483650" r:id="R409f214a1850422c"/>
-    <p:sldLayoutId xmlns:r="http://schemas.openxmlformats.org/officeDocument/2006/relationships" id="2147483651" r:id="Rab59e4dbd5f342f1"/>
-    <p:sldLayoutId xmlns:r="http://schemas.openxmlformats.org/officeDocument/2006/relationships" id="2147483652" r:id="Reaed609b6d5c459d"/>
-    <p:sldLayoutId xmlns:r="http://schemas.openxmlformats.org/officeDocument/2006/relationships" id="2147483653" r:id="Rd9b08e6cbe8d45fd"/>
-    <p:sldLayoutId xmlns:r="http://schemas.openxmlformats.org/officeDocument/2006/relationships" id="2147483654" r:id="R05fbdd9bc1504039"/>
+    <p:sldLayoutId xmlns:r="http://schemas.openxmlformats.org/officeDocument/2006/relationships" id="2147483649" r:id="R66e8e26ea68a422b"/>
+    <p:sldLayoutId xmlns:r="http://schemas.openxmlformats.org/officeDocument/2006/relationships" id="2147483650" r:id="Ra7479bd6b0b34284"/>
+    <p:sldLayoutId xmlns:r="http://schemas.openxmlformats.org/officeDocument/2006/relationships" id="2147483651" r:id="Rf65f244b880e45e1"/>
+    <p:sldLayoutId xmlns:r="http://schemas.openxmlformats.org/officeDocument/2006/relationships" id="2147483652" r:id="R64703041eca34edc"/>
+    <p:sldLayoutId xmlns:r="http://schemas.openxmlformats.org/officeDocument/2006/relationships" id="2147483653" r:id="R700ee1698c324b1a"/>
+    <p:sldLayoutId xmlns:r="http://schemas.openxmlformats.org/officeDocument/2006/relationships" id="2147483654" r:id="R2a2715c3ed654b9c"/>
   </p:sldLayoutIdLst>
   <p:txStyles>
     <p:titleStyle>
@@ -4063,7 +4063,7 @@
           <p:cNvPr id="5" name="">
             <a:extLst xmlns:a="http://schemas.openxmlformats.org/drawingml/2006/main">
               <a:ext uri="{FF2B5EF4-FFF2-40B4-BE49-F238E27FC236}">
-                <a16:creationId xmlns:a16="http://schemas.microsoft.com/office/drawing/2014/main" id="{A9B67473-B268-4AED-B879-EF65225F4568}"/>
+                <a16:creationId xmlns:a16="http://schemas.microsoft.com/office/drawing/2014/main" id="{072FE5BB-50AC-497C-8E83-2CA24416A914}"/>
               </a:ext>
             </a:extLst>
           </p:cNvPr>
@@ -4073,7 +4073,7 @@
           <p:nvPr/>
         </p:nvPicPr>
         <p:blipFill>
-          <a:blip xmlns:r="http://schemas.openxmlformats.org/officeDocument/2006/relationships" xmlns:a="http://schemas.openxmlformats.org/drawingml/2006/main" r:embed="Rf6dce6a1dab64dc4"/>
+          <a:blip xmlns:r="http://schemas.openxmlformats.org/officeDocument/2006/relationships" xmlns:a="http://schemas.openxmlformats.org/drawingml/2006/main" r:embed="R2e3f63e9f7714711"/>
           <a:srcRect xmlns:a="http://schemas.openxmlformats.org/drawingml/2006/main" l="0" t="27" r="0" b="27"/>
           <a:stretch xmlns:a="http://schemas.openxmlformats.org/drawingml/2006/main">
             <a:fillRect l="0" t="0" r="0" b="0"/>
@@ -4094,7 +4094,7 @@
           <p:cNvPr id="2" name="">
             <a:extLst xmlns:a="http://schemas.openxmlformats.org/drawingml/2006/main">
               <a:ext uri="{FF2B5EF4-FFF2-40B4-BE49-F238E27FC236}">
-                <a16:creationId xmlns:a16="http://schemas.microsoft.com/office/drawing/2014/main" id="{DD240B78-3C11-4A6D-9F4D-6356ECCC61CE}"/>
+                <a16:creationId xmlns:a16="http://schemas.microsoft.com/office/drawing/2014/main" id="{0EA54B02-4D0D-40B6-B1DD-485368420743}"/>
               </a:ext>
             </a:extLst>
           </p:cNvPr>
@@ -4185,7 +4185,7 @@
           <p:cNvPr id="3" name="">
             <a:extLst xmlns:a="http://schemas.openxmlformats.org/drawingml/2006/main">
               <a:ext uri="{FF2B5EF4-FFF2-40B4-BE49-F238E27FC236}">
-                <a16:creationId xmlns:a16="http://schemas.microsoft.com/office/drawing/2014/main" id="{E0908DBE-A730-4448-BA39-C257AD220820}"/>
+                <a16:creationId xmlns:a16="http://schemas.microsoft.com/office/drawing/2014/main" id="{E612C2A4-6C1D-4D44-A480-A4935380CBF8}"/>
               </a:ext>
             </a:extLst>
           </p:cNvPr>
@@ -4253,7 +4253,7 @@
           <p:cNvPr id="4" name="">
             <a:extLst xmlns:a="http://schemas.openxmlformats.org/drawingml/2006/main">
               <a:ext uri="{FF2B5EF4-FFF2-40B4-BE49-F238E27FC236}">
-                <a16:creationId xmlns:a16="http://schemas.microsoft.com/office/drawing/2014/main" id="{EEAE3F03-F373-4673-9310-8C8B45CB891A}"/>
+                <a16:creationId xmlns:a16="http://schemas.microsoft.com/office/drawing/2014/main" id="{BEF1887E-4537-46D9-977C-96C272AE933E}"/>
               </a:ext>
             </a:extLst>
           </p:cNvPr>
@@ -4319,7 +4319,7 @@
     </p:spTree>
     <p:extLst>
       <p:ext uri="{BB962C8B-B14F-4D97-AF65-F5344CB8AC3E}">
-        <p14:creationId xmlns:p14="http://schemas.microsoft.com/office/powerpoint/2010/main" val="1576514937"/>
+        <p14:creationId xmlns:p14="http://schemas.microsoft.com/office/powerpoint/2010/main" val="1983364745"/>
       </p:ext>
     </p:extLst>
   </p:cSld>
@@ -4350,7 +4350,7 @@
           <p:cNvPr id="13" name="">
             <a:extLst xmlns:a="http://schemas.openxmlformats.org/drawingml/2006/main">
               <a:ext uri="{FF2B5EF4-FFF2-40B4-BE49-F238E27FC236}">
-                <a16:creationId xmlns:a16="http://schemas.microsoft.com/office/drawing/2014/main" id="{009700FB-CFF5-4146-8349-FCFA115B6E21}"/>
+                <a16:creationId xmlns:a16="http://schemas.microsoft.com/office/drawing/2014/main" id="{C959609C-1C6C-47CE-9683-72FA20C1806F}"/>
               </a:ext>
             </a:extLst>
           </p:cNvPr>
@@ -4418,7 +4418,7 @@
           <p:cNvPr id="2" name="">
             <a:extLst xmlns:a="http://schemas.openxmlformats.org/drawingml/2006/main">
               <a:ext uri="{FF2B5EF4-FFF2-40B4-BE49-F238E27FC236}">
-                <a16:creationId xmlns:a16="http://schemas.microsoft.com/office/drawing/2014/main" id="{9487FD08-3722-4A64-97F3-7682CB35596E}"/>
+                <a16:creationId xmlns:a16="http://schemas.microsoft.com/office/drawing/2014/main" id="{3BFAAB51-08BF-4AE0-A23B-C39BA88F3E43}"/>
               </a:ext>
             </a:extLst>
           </p:cNvPr>
@@ -4486,7 +4486,7 @@
           <p:cNvPr id="3" name="">
             <a:extLst xmlns:a="http://schemas.openxmlformats.org/drawingml/2006/main">
               <a:ext uri="{FF2B5EF4-FFF2-40B4-BE49-F238E27FC236}">
-                <a16:creationId xmlns:a16="http://schemas.microsoft.com/office/drawing/2014/main" id="{43A243ED-AA14-47C7-8E5F-0B46A9FB4D3A}"/>
+                <a16:creationId xmlns:a16="http://schemas.microsoft.com/office/drawing/2014/main" id="{8C17FA4B-2F0B-42A5-BB30-F4147D3FD987}"/>
               </a:ext>
             </a:extLst>
           </p:cNvPr>
@@ -4554,7 +4554,7 @@
           <p:cNvPr id="4" name="">
             <a:extLst xmlns:a="http://schemas.openxmlformats.org/drawingml/2006/main">
               <a:ext uri="{FF2B5EF4-FFF2-40B4-BE49-F238E27FC236}">
-                <a16:creationId xmlns:a16="http://schemas.microsoft.com/office/drawing/2014/main" id="{B0373FED-77FD-4A38-8EA8-25AC219C0E64}"/>
+                <a16:creationId xmlns:a16="http://schemas.microsoft.com/office/drawing/2014/main" id="{510F1E10-A8A3-497C-92F6-8ECC51C18FAB}"/>
               </a:ext>
             </a:extLst>
           </p:cNvPr>
@@ -4622,7 +4622,7 @@
           <p:cNvPr id="5" name="">
             <a:extLst xmlns:a="http://schemas.openxmlformats.org/drawingml/2006/main">
               <a:ext uri="{FF2B5EF4-FFF2-40B4-BE49-F238E27FC236}">
-                <a16:creationId xmlns:a16="http://schemas.microsoft.com/office/drawing/2014/main" id="{9E852818-967C-4369-BA51-593F8C8FC653}"/>
+                <a16:creationId xmlns:a16="http://schemas.microsoft.com/office/drawing/2014/main" id="{647A1395-1823-4FFA-B1DE-4948AFF83BAE}"/>
               </a:ext>
             </a:extLst>
           </p:cNvPr>
@@ -4690,7 +4690,7 @@
           <p:cNvPr id="6" name="">
             <a:extLst xmlns:a="http://schemas.openxmlformats.org/drawingml/2006/main">
               <a:ext uri="{FF2B5EF4-FFF2-40B4-BE49-F238E27FC236}">
-                <a16:creationId xmlns:a16="http://schemas.microsoft.com/office/drawing/2014/main" id="{3A976AE9-2746-4F8E-865C-525B643B117F}"/>
+                <a16:creationId xmlns:a16="http://schemas.microsoft.com/office/drawing/2014/main" id="{15FAF1B8-4860-4995-905A-336CAF185278}"/>
               </a:ext>
             </a:extLst>
           </p:cNvPr>
@@ -4758,7 +4758,7 @@
           <p:cNvPr id="7" name="">
             <a:extLst xmlns:a="http://schemas.openxmlformats.org/drawingml/2006/main">
               <a:ext uri="{FF2B5EF4-FFF2-40B4-BE49-F238E27FC236}">
-                <a16:creationId xmlns:a16="http://schemas.microsoft.com/office/drawing/2014/main" id="{B4CAF615-3709-4F48-8178-BA413342256E}"/>
+                <a16:creationId xmlns:a16="http://schemas.microsoft.com/office/drawing/2014/main" id="{A1893A15-17A9-40C8-B2B0-E55488F524F1}"/>
               </a:ext>
             </a:extLst>
           </p:cNvPr>
@@ -4826,7 +4826,7 @@
           <p:cNvPr id="8" name="">
             <a:extLst xmlns:a="http://schemas.openxmlformats.org/drawingml/2006/main">
               <a:ext uri="{FF2B5EF4-FFF2-40B4-BE49-F238E27FC236}">
-                <a16:creationId xmlns:a16="http://schemas.microsoft.com/office/drawing/2014/main" id="{BBA60C47-E93D-47F2-B07E-C88048D6623C}"/>
+                <a16:creationId xmlns:a16="http://schemas.microsoft.com/office/drawing/2014/main" id="{1986058D-CEAB-4A51-8DEB-8C812D776104}"/>
               </a:ext>
             </a:extLst>
           </p:cNvPr>
@@ -4894,7 +4894,7 @@
           <p:cNvPr id="9" name="">
             <a:extLst xmlns:a="http://schemas.openxmlformats.org/drawingml/2006/main">
               <a:ext uri="{FF2B5EF4-FFF2-40B4-BE49-F238E27FC236}">
-                <a16:creationId xmlns:a16="http://schemas.microsoft.com/office/drawing/2014/main" id="{1A6A66C8-97CA-4B09-88CC-8D617628DC26}"/>
+                <a16:creationId xmlns:a16="http://schemas.microsoft.com/office/drawing/2014/main" id="{8E83F25C-6BEE-4E46-8206-52C0E661CCB9}"/>
               </a:ext>
             </a:extLst>
           </p:cNvPr>
@@ -4962,7 +4962,7 @@
           <p:cNvPr id="10" name="">
             <a:extLst xmlns:a="http://schemas.openxmlformats.org/drawingml/2006/main">
               <a:ext uri="{FF2B5EF4-FFF2-40B4-BE49-F238E27FC236}">
-                <a16:creationId xmlns:a16="http://schemas.microsoft.com/office/drawing/2014/main" id="{9852B8FD-083F-465D-9D2A-420B7D3D65B5}"/>
+                <a16:creationId xmlns:a16="http://schemas.microsoft.com/office/drawing/2014/main" id="{272AD276-6610-45DF-9AEA-E261DDC157AB}"/>
               </a:ext>
             </a:extLst>
           </p:cNvPr>
@@ -5030,7 +5030,7 @@
           <p:cNvPr id="11" name="">
             <a:extLst xmlns:a="http://schemas.openxmlformats.org/drawingml/2006/main">
               <a:ext uri="{FF2B5EF4-FFF2-40B4-BE49-F238E27FC236}">
-                <a16:creationId xmlns:a16="http://schemas.microsoft.com/office/drawing/2014/main" id="{89441D45-5858-431E-97DD-508DB65F8C3E}"/>
+                <a16:creationId xmlns:a16="http://schemas.microsoft.com/office/drawing/2014/main" id="{DDF5D5C8-CB16-45B9-BBAC-A0F522FD49CF}"/>
               </a:ext>
             </a:extLst>
           </p:cNvPr>
@@ -5098,7 +5098,7 @@
           <p:cNvPr id="12" name="">
             <a:extLst xmlns:a="http://schemas.openxmlformats.org/drawingml/2006/main">
               <a:ext uri="{FF2B5EF4-FFF2-40B4-BE49-F238E27FC236}">
-                <a16:creationId xmlns:a16="http://schemas.microsoft.com/office/drawing/2014/main" id="{05F871D9-1124-4AC0-9C36-429C0B176FC0}"/>
+                <a16:creationId xmlns:a16="http://schemas.microsoft.com/office/drawing/2014/main" id="{00CDF0AA-F505-45E3-8F09-DF273A442BEB}"/>
               </a:ext>
             </a:extLst>
           </p:cNvPr>
@@ -5164,7 +5164,7 @@
     </p:spTree>
     <p:extLst>
       <p:ext uri="{BB962C8B-B14F-4D97-AF65-F5344CB8AC3E}">
-        <p14:creationId xmlns:p14="http://schemas.microsoft.com/office/powerpoint/2010/main" val="1011602611"/>
+        <p14:creationId xmlns:p14="http://schemas.microsoft.com/office/powerpoint/2010/main" val="1880136608"/>
       </p:ext>
     </p:extLst>
   </p:cSld>
@@ -5195,7 +5195,7 @@
           <p:cNvPr id="13" name="">
             <a:extLst xmlns:a="http://schemas.openxmlformats.org/drawingml/2006/main">
               <a:ext uri="{FF2B5EF4-FFF2-40B4-BE49-F238E27FC236}">
-                <a16:creationId xmlns:a16="http://schemas.microsoft.com/office/drawing/2014/main" id="{A3FE29F0-F693-4E99-A7E6-A88060E7C4B0}"/>
+                <a16:creationId xmlns:a16="http://schemas.microsoft.com/office/drawing/2014/main" id="{6373D138-724C-47EC-A9C6-A7158AE96113}"/>
               </a:ext>
             </a:extLst>
           </p:cNvPr>
@@ -5263,7 +5263,7 @@
           <p:cNvPr id="2" name="">
             <a:extLst xmlns:a="http://schemas.openxmlformats.org/drawingml/2006/main">
               <a:ext uri="{FF2B5EF4-FFF2-40B4-BE49-F238E27FC236}">
-                <a16:creationId xmlns:a16="http://schemas.microsoft.com/office/drawing/2014/main" id="{96132238-A49A-4B2F-A890-B4989AD8C262}"/>
+                <a16:creationId xmlns:a16="http://schemas.microsoft.com/office/drawing/2014/main" id="{57C14A01-1731-48C8-9B51-0A47DC2925B2}"/>
               </a:ext>
             </a:extLst>
           </p:cNvPr>
@@ -5331,7 +5331,7 @@
           <p:cNvPr id="3" name="">
             <a:extLst xmlns:a="http://schemas.openxmlformats.org/drawingml/2006/main">
               <a:ext uri="{FF2B5EF4-FFF2-40B4-BE49-F238E27FC236}">
-                <a16:creationId xmlns:a16="http://schemas.microsoft.com/office/drawing/2014/main" id="{4183DBF6-D85F-464B-8DE3-E7F7330EA878}"/>
+                <a16:creationId xmlns:a16="http://schemas.microsoft.com/office/drawing/2014/main" id="{FE929E6D-69BD-4E46-AF94-F1FCBCAA1C7C}"/>
               </a:ext>
             </a:extLst>
           </p:cNvPr>
@@ -5399,7 +5399,7 @@
           <p:cNvPr id="4" name="">
             <a:extLst xmlns:a="http://schemas.openxmlformats.org/drawingml/2006/main">
               <a:ext uri="{FF2B5EF4-FFF2-40B4-BE49-F238E27FC236}">
-                <a16:creationId xmlns:a16="http://schemas.microsoft.com/office/drawing/2014/main" id="{F525395C-8CF3-4B52-B49D-7B3AB7A38F5B}"/>
+                <a16:creationId xmlns:a16="http://schemas.microsoft.com/office/drawing/2014/main" id="{B63C2D6B-2333-47A2-8BD6-C4C3A5B442ED}"/>
               </a:ext>
             </a:extLst>
           </p:cNvPr>
@@ -5467,7 +5467,7 @@
           <p:cNvPr id="5" name="">
             <a:extLst xmlns:a="http://schemas.openxmlformats.org/drawingml/2006/main">
               <a:ext uri="{FF2B5EF4-FFF2-40B4-BE49-F238E27FC236}">
-                <a16:creationId xmlns:a16="http://schemas.microsoft.com/office/drawing/2014/main" id="{ECF58113-55FC-4DF4-B99B-F0FBDD201E19}"/>
+                <a16:creationId xmlns:a16="http://schemas.microsoft.com/office/drawing/2014/main" id="{A9A46AC5-0D42-4757-8889-478627E5B0AF}"/>
               </a:ext>
             </a:extLst>
           </p:cNvPr>
@@ -5535,7 +5535,7 @@
           <p:cNvPr id="6" name="">
             <a:extLst xmlns:a="http://schemas.openxmlformats.org/drawingml/2006/main">
               <a:ext uri="{FF2B5EF4-FFF2-40B4-BE49-F238E27FC236}">
-                <a16:creationId xmlns:a16="http://schemas.microsoft.com/office/drawing/2014/main" id="{CF60A5AE-0DFB-408B-BD0A-751629C6A568}"/>
+                <a16:creationId xmlns:a16="http://schemas.microsoft.com/office/drawing/2014/main" id="{6B9027F2-D833-4D87-84E2-7FB17B40D871}"/>
               </a:ext>
             </a:extLst>
           </p:cNvPr>
@@ -5603,7 +5603,7 @@
           <p:cNvPr id="7" name="">
             <a:extLst xmlns:a="http://schemas.openxmlformats.org/drawingml/2006/main">
               <a:ext uri="{FF2B5EF4-FFF2-40B4-BE49-F238E27FC236}">
-                <a16:creationId xmlns:a16="http://schemas.microsoft.com/office/drawing/2014/main" id="{DF0439E6-EA13-4062-A924-82B9C83DD5DF}"/>
+                <a16:creationId xmlns:a16="http://schemas.microsoft.com/office/drawing/2014/main" id="{FE97F960-02B3-4943-B3F5-78FDC8FBA081}"/>
               </a:ext>
             </a:extLst>
           </p:cNvPr>
@@ -5671,7 +5671,7 @@
           <p:cNvPr id="8" name="">
             <a:extLst xmlns:a="http://schemas.openxmlformats.org/drawingml/2006/main">
               <a:ext uri="{FF2B5EF4-FFF2-40B4-BE49-F238E27FC236}">
-                <a16:creationId xmlns:a16="http://schemas.microsoft.com/office/drawing/2014/main" id="{0B56E9FD-0758-467C-9025-833FB5FE5591}"/>
+                <a16:creationId xmlns:a16="http://schemas.microsoft.com/office/drawing/2014/main" id="{6E18EEF4-123C-4E4D-BB66-C45DFBA73BCB}"/>
               </a:ext>
             </a:extLst>
           </p:cNvPr>
@@ -5739,7 +5739,7 @@
           <p:cNvPr id="9" name="">
             <a:extLst xmlns:a="http://schemas.openxmlformats.org/drawingml/2006/main">
               <a:ext uri="{FF2B5EF4-FFF2-40B4-BE49-F238E27FC236}">
-                <a16:creationId xmlns:a16="http://schemas.microsoft.com/office/drawing/2014/main" id="{12562F75-03B3-487D-BE59-47C1EE7FDA94}"/>
+                <a16:creationId xmlns:a16="http://schemas.microsoft.com/office/drawing/2014/main" id="{61145740-2ECA-48BF-ABA0-FFF36026BEEE}"/>
               </a:ext>
             </a:extLst>
           </p:cNvPr>
@@ -5807,7 +5807,7 @@
           <p:cNvPr id="10" name="">
             <a:extLst xmlns:a="http://schemas.openxmlformats.org/drawingml/2006/main">
               <a:ext uri="{FF2B5EF4-FFF2-40B4-BE49-F238E27FC236}">
-                <a16:creationId xmlns:a16="http://schemas.microsoft.com/office/drawing/2014/main" id="{6DD50F87-20A8-41DF-88A5-7E1F1098E560}"/>
+                <a16:creationId xmlns:a16="http://schemas.microsoft.com/office/drawing/2014/main" id="{56E18295-BACF-43EF-9140-2F6FC5603A55}"/>
               </a:ext>
             </a:extLst>
           </p:cNvPr>
@@ -5875,7 +5875,7 @@
           <p:cNvPr id="11" name="">
             <a:extLst xmlns:a="http://schemas.openxmlformats.org/drawingml/2006/main">
               <a:ext uri="{FF2B5EF4-FFF2-40B4-BE49-F238E27FC236}">
-                <a16:creationId xmlns:a16="http://schemas.microsoft.com/office/drawing/2014/main" id="{39700AE8-F01B-4552-851D-CBE6F48BFC36}"/>
+                <a16:creationId xmlns:a16="http://schemas.microsoft.com/office/drawing/2014/main" id="{44E9BFA8-062B-4E6B-B7E4-509DA5926D69}"/>
               </a:ext>
             </a:extLst>
           </p:cNvPr>
@@ -5943,7 +5943,7 @@
           <p:cNvPr id="12" name="">
             <a:extLst xmlns:a="http://schemas.openxmlformats.org/drawingml/2006/main">
               <a:ext uri="{FF2B5EF4-FFF2-40B4-BE49-F238E27FC236}">
-                <a16:creationId xmlns:a16="http://schemas.microsoft.com/office/drawing/2014/main" id="{E4B4CE7F-5D99-47C5-808A-44442069D1EF}"/>
+                <a16:creationId xmlns:a16="http://schemas.microsoft.com/office/drawing/2014/main" id="{F90709B9-F970-4EEE-9721-5A44220B4F0D}"/>
               </a:ext>
             </a:extLst>
           </p:cNvPr>
@@ -6009,7 +6009,7 @@
     </p:spTree>
     <p:extLst>
       <p:ext uri="{BB962C8B-B14F-4D97-AF65-F5344CB8AC3E}">
-        <p14:creationId xmlns:p14="http://schemas.microsoft.com/office/powerpoint/2010/main" val="976325040"/>
+        <p14:creationId xmlns:p14="http://schemas.microsoft.com/office/powerpoint/2010/main" val="882017957"/>
       </p:ext>
     </p:extLst>
   </p:cSld>
@@ -6040,7 +6040,7 @@
           <p:cNvPr id="13" name="">
             <a:extLst xmlns:a="http://schemas.openxmlformats.org/drawingml/2006/main">
               <a:ext uri="{FF2B5EF4-FFF2-40B4-BE49-F238E27FC236}">
-                <a16:creationId xmlns:a16="http://schemas.microsoft.com/office/drawing/2014/main" id="{541B1702-D6C3-454F-86C5-300ED609433E}"/>
+                <a16:creationId xmlns:a16="http://schemas.microsoft.com/office/drawing/2014/main" id="{19223083-F00F-4548-9CD8-A8F6CEC6FA48}"/>
               </a:ext>
             </a:extLst>
           </p:cNvPr>
@@ -6108,7 +6108,7 @@
           <p:cNvPr id="2" name="">
             <a:extLst xmlns:a="http://schemas.openxmlformats.org/drawingml/2006/main">
               <a:ext uri="{FF2B5EF4-FFF2-40B4-BE49-F238E27FC236}">
-                <a16:creationId xmlns:a16="http://schemas.microsoft.com/office/drawing/2014/main" id="{E6AFCC84-4D1B-4B40-97AF-00730546A1E9}"/>
+                <a16:creationId xmlns:a16="http://schemas.microsoft.com/office/drawing/2014/main" id="{3A50FA2E-236A-4F3B-B184-3BECF07F6199}"/>
               </a:ext>
             </a:extLst>
           </p:cNvPr>
@@ -6176,7 +6176,7 @@
           <p:cNvPr id="3" name="">
             <a:extLst xmlns:a="http://schemas.openxmlformats.org/drawingml/2006/main">
               <a:ext uri="{FF2B5EF4-FFF2-40B4-BE49-F238E27FC236}">
-                <a16:creationId xmlns:a16="http://schemas.microsoft.com/office/drawing/2014/main" id="{1B337D77-580C-4F33-835C-997175EB9F85}"/>
+                <a16:creationId xmlns:a16="http://schemas.microsoft.com/office/drawing/2014/main" id="{98C243B4-C2A6-4269-82DD-6F35FD266813}"/>
               </a:ext>
             </a:extLst>
           </p:cNvPr>
@@ -6244,7 +6244,7 @@
           <p:cNvPr id="4" name="">
             <a:extLst xmlns:a="http://schemas.openxmlformats.org/drawingml/2006/main">
               <a:ext uri="{FF2B5EF4-FFF2-40B4-BE49-F238E27FC236}">
-                <a16:creationId xmlns:a16="http://schemas.microsoft.com/office/drawing/2014/main" id="{38CB9AEE-0B76-4C8A-BE29-29F1183FAA8E}"/>
+                <a16:creationId xmlns:a16="http://schemas.microsoft.com/office/drawing/2014/main" id="{B1B7A55E-6BE3-4C62-920F-C948970B9DD2}"/>
               </a:ext>
             </a:extLst>
           </p:cNvPr>
@@ -6312,7 +6312,7 @@
           <p:cNvPr id="5" name="">
             <a:extLst xmlns:a="http://schemas.openxmlformats.org/drawingml/2006/main">
               <a:ext uri="{FF2B5EF4-FFF2-40B4-BE49-F238E27FC236}">
-                <a16:creationId xmlns:a16="http://schemas.microsoft.com/office/drawing/2014/main" id="{9CF4DE03-17B6-439F-BD19-97D5B8ED428A}"/>
+                <a16:creationId xmlns:a16="http://schemas.microsoft.com/office/drawing/2014/main" id="{9A133262-A299-492A-83D9-10FAB9B7442F}"/>
               </a:ext>
             </a:extLst>
           </p:cNvPr>
@@ -6380,7 +6380,7 @@
           <p:cNvPr id="6" name="">
             <a:extLst xmlns:a="http://schemas.openxmlformats.org/drawingml/2006/main">
               <a:ext uri="{FF2B5EF4-FFF2-40B4-BE49-F238E27FC236}">
-                <a16:creationId xmlns:a16="http://schemas.microsoft.com/office/drawing/2014/main" id="{919BE94C-FEDD-4575-BD9E-2A39F92BD585}"/>
+                <a16:creationId xmlns:a16="http://schemas.microsoft.com/office/drawing/2014/main" id="{17F851D8-80E9-4CA1-9E2C-49D9D50F1481}"/>
               </a:ext>
             </a:extLst>
           </p:cNvPr>
@@ -6448,7 +6448,7 @@
           <p:cNvPr id="7" name="">
             <a:extLst xmlns:a="http://schemas.openxmlformats.org/drawingml/2006/main">
               <a:ext uri="{FF2B5EF4-FFF2-40B4-BE49-F238E27FC236}">
-                <a16:creationId xmlns:a16="http://schemas.microsoft.com/office/drawing/2014/main" id="{EB864678-27C9-4F49-8779-B05D85B98D46}"/>
+                <a16:creationId xmlns:a16="http://schemas.microsoft.com/office/drawing/2014/main" id="{03724DB7-A863-433F-B637-FD7DD2569829}"/>
               </a:ext>
             </a:extLst>
           </p:cNvPr>
@@ -6516,7 +6516,7 @@
           <p:cNvPr id="8" name="">
             <a:extLst xmlns:a="http://schemas.openxmlformats.org/drawingml/2006/main">
               <a:ext uri="{FF2B5EF4-FFF2-40B4-BE49-F238E27FC236}">
-                <a16:creationId xmlns:a16="http://schemas.microsoft.com/office/drawing/2014/main" id="{E8F2812F-CE9D-4DFC-83F1-9E6B7040A590}"/>
+                <a16:creationId xmlns:a16="http://schemas.microsoft.com/office/drawing/2014/main" id="{35A6D2FF-66A8-4839-A71F-F6397FCCFB21}"/>
               </a:ext>
             </a:extLst>
           </p:cNvPr>
@@ -6584,7 +6584,7 @@
           <p:cNvPr id="9" name="">
             <a:extLst xmlns:a="http://schemas.openxmlformats.org/drawingml/2006/main">
               <a:ext uri="{FF2B5EF4-FFF2-40B4-BE49-F238E27FC236}">
-                <a16:creationId xmlns:a16="http://schemas.microsoft.com/office/drawing/2014/main" id="{E0204CB4-D170-4C3C-BBD4-4B08B9B9E222}"/>
+                <a16:creationId xmlns:a16="http://schemas.microsoft.com/office/drawing/2014/main" id="{0C5A659D-F9BA-4977-A7C2-9722E613685C}"/>
               </a:ext>
             </a:extLst>
           </p:cNvPr>
@@ -6652,7 +6652,7 @@
           <p:cNvPr id="10" name="">
             <a:extLst xmlns:a="http://schemas.openxmlformats.org/drawingml/2006/main">
               <a:ext uri="{FF2B5EF4-FFF2-40B4-BE49-F238E27FC236}">
-                <a16:creationId xmlns:a16="http://schemas.microsoft.com/office/drawing/2014/main" id="{36EF7A0E-C3E3-446D-A22F-E28A67ACABFB}"/>
+                <a16:creationId xmlns:a16="http://schemas.microsoft.com/office/drawing/2014/main" id="{A256BDF5-CC56-45F2-A877-3F141EEB6B9C}"/>
               </a:ext>
             </a:extLst>
           </p:cNvPr>
@@ -6720,7 +6720,7 @@
           <p:cNvPr id="11" name="">
             <a:extLst xmlns:a="http://schemas.openxmlformats.org/drawingml/2006/main">
               <a:ext uri="{FF2B5EF4-FFF2-40B4-BE49-F238E27FC236}">
-                <a16:creationId xmlns:a16="http://schemas.microsoft.com/office/drawing/2014/main" id="{1655143F-D7C7-41E7-904B-BA6BAC1A3416}"/>
+                <a16:creationId xmlns:a16="http://schemas.microsoft.com/office/drawing/2014/main" id="{8E8C141D-53F7-473A-A6AB-84D1A4F5F3FF}"/>
               </a:ext>
             </a:extLst>
           </p:cNvPr>
@@ -6788,7 +6788,7 @@
           <p:cNvPr id="12" name="">
             <a:extLst xmlns:a="http://schemas.openxmlformats.org/drawingml/2006/main">
               <a:ext uri="{FF2B5EF4-FFF2-40B4-BE49-F238E27FC236}">
-                <a16:creationId xmlns:a16="http://schemas.microsoft.com/office/drawing/2014/main" id="{0E67977E-FB43-4ACE-B907-9E080AD6308F}"/>
+                <a16:creationId xmlns:a16="http://schemas.microsoft.com/office/drawing/2014/main" id="{7C51747F-D33E-450B-9772-2465B07F3962}"/>
               </a:ext>
             </a:extLst>
           </p:cNvPr>
@@ -6854,7 +6854,7 @@
     </p:spTree>
     <p:extLst>
       <p:ext uri="{BB962C8B-B14F-4D97-AF65-F5344CB8AC3E}">
-        <p14:creationId xmlns:p14="http://schemas.microsoft.com/office/powerpoint/2010/main" val="1241069470"/>
+        <p14:creationId xmlns:p14="http://schemas.microsoft.com/office/powerpoint/2010/main" val="1313534996"/>
       </p:ext>
     </p:extLst>
   </p:cSld>
@@ -6885,7 +6885,7 @@
           <p:cNvPr id="3" name="">
             <a:extLst xmlns:a="http://schemas.openxmlformats.org/drawingml/2006/main">
               <a:ext uri="{FF2B5EF4-FFF2-40B4-BE49-F238E27FC236}">
-                <a16:creationId xmlns:a16="http://schemas.microsoft.com/office/drawing/2014/main" id="{3D45C779-302D-4CF2-85CB-DA1C9ED70396}"/>
+                <a16:creationId xmlns:a16="http://schemas.microsoft.com/office/drawing/2014/main" id="{2BCB1D22-D708-4CF9-8100-B15E162E7B5B}"/>
               </a:ext>
             </a:extLst>
           </p:cNvPr>
@@ -6953,7 +6953,7 @@
           <p:cNvPr id="2" name="">
             <a:extLst xmlns:a="http://schemas.openxmlformats.org/drawingml/2006/main">
               <a:ext uri="{FF2B5EF4-FFF2-40B4-BE49-F238E27FC236}">
-                <a16:creationId xmlns:a16="http://schemas.microsoft.com/office/drawing/2014/main" id="{DCEFDE08-D603-4E76-B5D6-024127F03EB4}"/>
+                <a16:creationId xmlns:a16="http://schemas.microsoft.com/office/drawing/2014/main" id="{138AD107-3B1B-4629-93B0-088A8303D949}"/>
               </a:ext>
             </a:extLst>
           </p:cNvPr>
@@ -7019,7 +7019,7 @@
     </p:spTree>
     <p:extLst>
       <p:ext uri="{BB962C8B-B14F-4D97-AF65-F5344CB8AC3E}">
-        <p14:creationId xmlns:p14="http://schemas.microsoft.com/office/powerpoint/2010/main" val="364717260"/>
+        <p14:creationId xmlns:p14="http://schemas.microsoft.com/office/powerpoint/2010/main" val="2130953738"/>
       </p:ext>
     </p:extLst>
   </p:cSld>
@@ -7050,7 +7050,7 @@
           <p:cNvPr id="9" name="">
             <a:extLst xmlns:a="http://schemas.openxmlformats.org/drawingml/2006/main">
               <a:ext uri="{FF2B5EF4-FFF2-40B4-BE49-F238E27FC236}">
-                <a16:creationId xmlns:a16="http://schemas.microsoft.com/office/drawing/2014/main" id="{EACADFB8-4E4B-48AC-8E6D-5DCF062461A6}"/>
+                <a16:creationId xmlns:a16="http://schemas.microsoft.com/office/drawing/2014/main" id="{2705BECF-D2EB-4119-81A0-9EB5F79BC3E2}"/>
               </a:ext>
             </a:extLst>
           </p:cNvPr>
@@ -7118,7 +7118,7 @@
           <p:cNvPr id="2" name="">
             <a:extLst xmlns:a="http://schemas.openxmlformats.org/drawingml/2006/main">
               <a:ext uri="{FF2B5EF4-FFF2-40B4-BE49-F238E27FC236}">
-                <a16:creationId xmlns:a16="http://schemas.microsoft.com/office/drawing/2014/main" id="{112E08E7-C9CF-458F-BA2E-CE718C69B30A}"/>
+                <a16:creationId xmlns:a16="http://schemas.microsoft.com/office/drawing/2014/main" id="{263697A3-9CDB-4A06-B199-C62ABA8B9901}"/>
               </a:ext>
             </a:extLst>
           </p:cNvPr>
@@ -7186,7 +7186,7 @@
           <p:cNvPr id="3" name="">
             <a:extLst xmlns:a="http://schemas.openxmlformats.org/drawingml/2006/main">
               <a:ext uri="{FF2B5EF4-FFF2-40B4-BE49-F238E27FC236}">
-                <a16:creationId xmlns:a16="http://schemas.microsoft.com/office/drawing/2014/main" id="{62D02C8F-93BD-4A8B-B78B-1E152C8964AC}"/>
+                <a16:creationId xmlns:a16="http://schemas.microsoft.com/office/drawing/2014/main" id="{AAE56BA3-229F-49BD-BC69-3E164481CA3F}"/>
               </a:ext>
             </a:extLst>
           </p:cNvPr>
@@ -7254,7 +7254,7 @@
           <p:cNvPr id="4" name="">
             <a:extLst xmlns:a="http://schemas.openxmlformats.org/drawingml/2006/main">
               <a:ext uri="{FF2B5EF4-FFF2-40B4-BE49-F238E27FC236}">
-                <a16:creationId xmlns:a16="http://schemas.microsoft.com/office/drawing/2014/main" id="{F29DE85F-A19D-4DB6-B933-6F7EB97802CE}"/>
+                <a16:creationId xmlns:a16="http://schemas.microsoft.com/office/drawing/2014/main" id="{806D6131-D003-4547-BC1A-85F1A7BBAD09}"/>
               </a:ext>
             </a:extLst>
           </p:cNvPr>
@@ -7380,7 +7380,7 @@
           <p:cNvPr id="5" name="">
             <a:extLst xmlns:a="http://schemas.openxmlformats.org/drawingml/2006/main">
               <a:ext uri="{FF2B5EF4-FFF2-40B4-BE49-F238E27FC236}">
-                <a16:creationId xmlns:a16="http://schemas.microsoft.com/office/drawing/2014/main" id="{2BCA7B9E-4328-418F-8499-F833CC379190}"/>
+                <a16:creationId xmlns:a16="http://schemas.microsoft.com/office/drawing/2014/main" id="{F736EE82-44A9-4884-BFD2-6EB1B639D92D}"/>
               </a:ext>
             </a:extLst>
           </p:cNvPr>
@@ -7448,7 +7448,7 @@
           <p:cNvPr id="6" name="">
             <a:extLst xmlns:a="http://schemas.openxmlformats.org/drawingml/2006/main">
               <a:ext uri="{FF2B5EF4-FFF2-40B4-BE49-F238E27FC236}">
-                <a16:creationId xmlns:a16="http://schemas.microsoft.com/office/drawing/2014/main" id="{6B4DBE57-36CB-4A46-A157-F8A037C8A1BD}"/>
+                <a16:creationId xmlns:a16="http://schemas.microsoft.com/office/drawing/2014/main" id="{824CC4D1-B64E-4540-9D0F-D9016EFA69D5}"/>
               </a:ext>
             </a:extLst>
           </p:cNvPr>
@@ -7574,7 +7574,7 @@
           <p:cNvPr id="7" name="">
             <a:extLst xmlns:a="http://schemas.openxmlformats.org/drawingml/2006/main">
               <a:ext uri="{FF2B5EF4-FFF2-40B4-BE49-F238E27FC236}">
-                <a16:creationId xmlns:a16="http://schemas.microsoft.com/office/drawing/2014/main" id="{3227BBEF-C855-44DA-AB66-D5D10FF6FC14}"/>
+                <a16:creationId xmlns:a16="http://schemas.microsoft.com/office/drawing/2014/main" id="{BEEA044F-C694-4798-8193-1219AD0FF983}"/>
               </a:ext>
             </a:extLst>
           </p:cNvPr>
@@ -7642,7 +7642,7 @@
           <p:cNvPr id="8" name="">
             <a:extLst xmlns:a="http://schemas.openxmlformats.org/drawingml/2006/main">
               <a:ext uri="{FF2B5EF4-FFF2-40B4-BE49-F238E27FC236}">
-                <a16:creationId xmlns:a16="http://schemas.microsoft.com/office/drawing/2014/main" id="{B597304F-069C-4C0B-A70F-4B83C19F9A10}"/>
+                <a16:creationId xmlns:a16="http://schemas.microsoft.com/office/drawing/2014/main" id="{A6EA3D21-BACA-4019-A3B6-782854DD825A}"/>
               </a:ext>
             </a:extLst>
           </p:cNvPr>
@@ -7708,7 +7708,7 @@
     </p:spTree>
     <p:extLst>
       <p:ext uri="{BB962C8B-B14F-4D97-AF65-F5344CB8AC3E}">
-        <p14:creationId xmlns:p14="http://schemas.microsoft.com/office/powerpoint/2010/main" val="1743449718"/>
+        <p14:creationId xmlns:p14="http://schemas.microsoft.com/office/powerpoint/2010/main" val="1643182496"/>
       </p:ext>
     </p:extLst>
   </p:cSld>
@@ -7739,7 +7739,7 @@
           <p:cNvPr id="13" name="">
             <a:extLst xmlns:a="http://schemas.openxmlformats.org/drawingml/2006/main">
               <a:ext uri="{FF2B5EF4-FFF2-40B4-BE49-F238E27FC236}">
-                <a16:creationId xmlns:a16="http://schemas.microsoft.com/office/drawing/2014/main" id="{3C9B8F4C-485C-4EFC-894C-7EB1BA382B2F}"/>
+                <a16:creationId xmlns:a16="http://schemas.microsoft.com/office/drawing/2014/main" id="{EA5E5144-A6F0-437D-9ABC-7BE3ECA432F0}"/>
               </a:ext>
             </a:extLst>
           </p:cNvPr>
@@ -7807,7 +7807,7 @@
           <p:cNvPr id="2" name="">
             <a:extLst xmlns:a="http://schemas.openxmlformats.org/drawingml/2006/main">
               <a:ext uri="{FF2B5EF4-FFF2-40B4-BE49-F238E27FC236}">
-                <a16:creationId xmlns:a16="http://schemas.microsoft.com/office/drawing/2014/main" id="{059A3286-81F8-4B2A-83DB-396D997402BA}"/>
+                <a16:creationId xmlns:a16="http://schemas.microsoft.com/office/drawing/2014/main" id="{46B0BAC0-4EA5-40ED-9435-6279855445D8}"/>
               </a:ext>
             </a:extLst>
           </p:cNvPr>
@@ -7875,7 +7875,7 @@
           <p:cNvPr id="3" name="">
             <a:extLst xmlns:a="http://schemas.openxmlformats.org/drawingml/2006/main">
               <a:ext uri="{FF2B5EF4-FFF2-40B4-BE49-F238E27FC236}">
-                <a16:creationId xmlns:a16="http://schemas.microsoft.com/office/drawing/2014/main" id="{3891EA54-910F-4362-AAE5-1EDE738552B9}"/>
+                <a16:creationId xmlns:a16="http://schemas.microsoft.com/office/drawing/2014/main" id="{08290D08-2886-4775-A45B-4E7CA8C73C95}"/>
               </a:ext>
             </a:extLst>
           </p:cNvPr>
@@ -7943,7 +7943,7 @@
           <p:cNvPr id="4" name="">
             <a:extLst xmlns:a="http://schemas.openxmlformats.org/drawingml/2006/main">
               <a:ext uri="{FF2B5EF4-FFF2-40B4-BE49-F238E27FC236}">
-                <a16:creationId xmlns:a16="http://schemas.microsoft.com/office/drawing/2014/main" id="{A619809E-F5BC-4FEE-90CA-036D90213AB3}"/>
+                <a16:creationId xmlns:a16="http://schemas.microsoft.com/office/drawing/2014/main" id="{B50737D1-54A0-49CB-9B64-0AA628A9CE7F}"/>
               </a:ext>
             </a:extLst>
           </p:cNvPr>
@@ -8011,7 +8011,7 @@
           <p:cNvPr id="5" name="">
             <a:extLst xmlns:a="http://schemas.openxmlformats.org/drawingml/2006/main">
               <a:ext uri="{FF2B5EF4-FFF2-40B4-BE49-F238E27FC236}">
-                <a16:creationId xmlns:a16="http://schemas.microsoft.com/office/drawing/2014/main" id="{51A5409A-74E2-4F33-97AA-047FF376176F}"/>
+                <a16:creationId xmlns:a16="http://schemas.microsoft.com/office/drawing/2014/main" id="{4ED0877E-9F6B-4C20-A315-1FE7241C51B5}"/>
               </a:ext>
             </a:extLst>
           </p:cNvPr>
@@ -8079,7 +8079,7 @@
           <p:cNvPr id="6" name="">
             <a:extLst xmlns:a="http://schemas.openxmlformats.org/drawingml/2006/main">
               <a:ext uri="{FF2B5EF4-FFF2-40B4-BE49-F238E27FC236}">
-                <a16:creationId xmlns:a16="http://schemas.microsoft.com/office/drawing/2014/main" id="{4A69EA2C-83AE-4B27-9174-1BCC5480B406}"/>
+                <a16:creationId xmlns:a16="http://schemas.microsoft.com/office/drawing/2014/main" id="{F1984AC5-0DDD-4C71-A72D-A38931B0CDC7}"/>
               </a:ext>
             </a:extLst>
           </p:cNvPr>
@@ -8147,7 +8147,7 @@
           <p:cNvPr id="7" name="">
             <a:extLst xmlns:a="http://schemas.openxmlformats.org/drawingml/2006/main">
               <a:ext uri="{FF2B5EF4-FFF2-40B4-BE49-F238E27FC236}">
-                <a16:creationId xmlns:a16="http://schemas.microsoft.com/office/drawing/2014/main" id="{7BB8BAE1-E20C-40EC-80E4-D56D4550EBD2}"/>
+                <a16:creationId xmlns:a16="http://schemas.microsoft.com/office/drawing/2014/main" id="{CA0FC4D4-12B4-4894-9C09-0F49156B9C6D}"/>
               </a:ext>
             </a:extLst>
           </p:cNvPr>
@@ -8215,7 +8215,7 @@
           <p:cNvPr id="8" name="">
             <a:extLst xmlns:a="http://schemas.openxmlformats.org/drawingml/2006/main">
               <a:ext uri="{FF2B5EF4-FFF2-40B4-BE49-F238E27FC236}">
-                <a16:creationId xmlns:a16="http://schemas.microsoft.com/office/drawing/2014/main" id="{E3C5E9AF-E853-4179-ABD6-AC6EB804629F}"/>
+                <a16:creationId xmlns:a16="http://schemas.microsoft.com/office/drawing/2014/main" id="{9F7DA16C-88FE-4276-9E4D-03691C39E723}"/>
               </a:ext>
             </a:extLst>
           </p:cNvPr>
@@ -8283,7 +8283,7 @@
           <p:cNvPr id="9" name="">
             <a:extLst xmlns:a="http://schemas.openxmlformats.org/drawingml/2006/main">
               <a:ext uri="{FF2B5EF4-FFF2-40B4-BE49-F238E27FC236}">
-                <a16:creationId xmlns:a16="http://schemas.microsoft.com/office/drawing/2014/main" id="{1276E809-E227-4260-AD33-87792167A1BC}"/>
+                <a16:creationId xmlns:a16="http://schemas.microsoft.com/office/drawing/2014/main" id="{54927466-10C2-41A8-A1E8-291E92852977}"/>
               </a:ext>
             </a:extLst>
           </p:cNvPr>
@@ -8351,7 +8351,7 @@
           <p:cNvPr id="10" name="">
             <a:extLst xmlns:a="http://schemas.openxmlformats.org/drawingml/2006/main">
               <a:ext uri="{FF2B5EF4-FFF2-40B4-BE49-F238E27FC236}">
-                <a16:creationId xmlns:a16="http://schemas.microsoft.com/office/drawing/2014/main" id="{510A180E-1588-45AA-8374-DE56EE87493F}"/>
+                <a16:creationId xmlns:a16="http://schemas.microsoft.com/office/drawing/2014/main" id="{05351292-7ECA-4B69-8253-880077CF0201}"/>
               </a:ext>
             </a:extLst>
           </p:cNvPr>
@@ -8419,7 +8419,7 @@
           <p:cNvPr id="11" name="">
             <a:extLst xmlns:a="http://schemas.openxmlformats.org/drawingml/2006/main">
               <a:ext uri="{FF2B5EF4-FFF2-40B4-BE49-F238E27FC236}">
-                <a16:creationId xmlns:a16="http://schemas.microsoft.com/office/drawing/2014/main" id="{7D2FF3E6-9F69-4FEC-8AB3-13AE7713F68E}"/>
+                <a16:creationId xmlns:a16="http://schemas.microsoft.com/office/drawing/2014/main" id="{83FAD753-76DB-4C12-BDE7-AC386AA2769D}"/>
               </a:ext>
             </a:extLst>
           </p:cNvPr>
@@ -8487,7 +8487,7 @@
           <p:cNvPr id="12" name="">
             <a:extLst xmlns:a="http://schemas.openxmlformats.org/drawingml/2006/main">
               <a:ext uri="{FF2B5EF4-FFF2-40B4-BE49-F238E27FC236}">
-                <a16:creationId xmlns:a16="http://schemas.microsoft.com/office/drawing/2014/main" id="{6D7D27E2-67C9-48BA-9A42-E30D2E81F603}"/>
+                <a16:creationId xmlns:a16="http://schemas.microsoft.com/office/drawing/2014/main" id="{AB8E310A-98F6-4F19-BE17-F21C73C82566}"/>
               </a:ext>
             </a:extLst>
           </p:cNvPr>
@@ -8553,7 +8553,7 @@
     </p:spTree>
     <p:extLst>
       <p:ext uri="{BB962C8B-B14F-4D97-AF65-F5344CB8AC3E}">
-        <p14:creationId xmlns:p14="http://schemas.microsoft.com/office/powerpoint/2010/main" val="1825602620"/>
+        <p14:creationId xmlns:p14="http://schemas.microsoft.com/office/powerpoint/2010/main" val="1700095990"/>
       </p:ext>
     </p:extLst>
   </p:cSld>
@@ -8584,7 +8584,7 @@
           <p:cNvPr id="11" name="">
             <a:extLst xmlns:a="http://schemas.openxmlformats.org/drawingml/2006/main">
               <a:ext uri="{FF2B5EF4-FFF2-40B4-BE49-F238E27FC236}">
-                <a16:creationId xmlns:a16="http://schemas.microsoft.com/office/drawing/2014/main" id="{93D9FC31-52DF-4962-BB96-DCAB82098A3A}"/>
+                <a16:creationId xmlns:a16="http://schemas.microsoft.com/office/drawing/2014/main" id="{5557CDC4-1133-49E6-AF1D-9CA3111956BA}"/>
               </a:ext>
             </a:extLst>
           </p:cNvPr>
@@ -8652,7 +8652,7 @@
           <p:cNvPr id="2" name="">
             <a:extLst xmlns:a="http://schemas.openxmlformats.org/drawingml/2006/main">
               <a:ext uri="{FF2B5EF4-FFF2-40B4-BE49-F238E27FC236}">
-                <a16:creationId xmlns:a16="http://schemas.microsoft.com/office/drawing/2014/main" id="{0A474968-38DE-46C8-A0B7-83A6AE454E01}"/>
+                <a16:creationId xmlns:a16="http://schemas.microsoft.com/office/drawing/2014/main" id="{056889D6-B07A-4265-AD95-1193AF7382F9}"/>
               </a:ext>
             </a:extLst>
           </p:cNvPr>
@@ -8720,7 +8720,7 @@
           <p:cNvPr id="3" name="">
             <a:extLst xmlns:a="http://schemas.openxmlformats.org/drawingml/2006/main">
               <a:ext uri="{FF2B5EF4-FFF2-40B4-BE49-F238E27FC236}">
-                <a16:creationId xmlns:a16="http://schemas.microsoft.com/office/drawing/2014/main" id="{947183D4-B78F-437A-B637-F67ABB20309B}"/>
+                <a16:creationId xmlns:a16="http://schemas.microsoft.com/office/drawing/2014/main" id="{346EA010-B1FF-4F04-B1EF-E396B3C62F4E}"/>
               </a:ext>
             </a:extLst>
           </p:cNvPr>
@@ -8788,7 +8788,7 @@
           <p:cNvPr id="4" name="">
             <a:extLst xmlns:a="http://schemas.openxmlformats.org/drawingml/2006/main">
               <a:ext uri="{FF2B5EF4-FFF2-40B4-BE49-F238E27FC236}">
-                <a16:creationId xmlns:a16="http://schemas.microsoft.com/office/drawing/2014/main" id="{D5E04A85-1D6C-47CC-BE4A-E517907F9C49}"/>
+                <a16:creationId xmlns:a16="http://schemas.microsoft.com/office/drawing/2014/main" id="{3F3ACEF2-2FA4-448F-B61C-001BA6F47FE1}"/>
               </a:ext>
             </a:extLst>
           </p:cNvPr>
@@ -8856,7 +8856,7 @@
           <p:cNvPr id="5" name="">
             <a:extLst xmlns:a="http://schemas.openxmlformats.org/drawingml/2006/main">
               <a:ext uri="{FF2B5EF4-FFF2-40B4-BE49-F238E27FC236}">
-                <a16:creationId xmlns:a16="http://schemas.microsoft.com/office/drawing/2014/main" id="{DAD50491-F2C0-455A-AC7C-726A521BA929}"/>
+                <a16:creationId xmlns:a16="http://schemas.microsoft.com/office/drawing/2014/main" id="{C0FAF7DA-DC62-4AF6-8382-362CA7E29F7A}"/>
               </a:ext>
             </a:extLst>
           </p:cNvPr>
@@ -8924,7 +8924,7 @@
           <p:cNvPr id="6" name="">
             <a:extLst xmlns:a="http://schemas.openxmlformats.org/drawingml/2006/main">
               <a:ext uri="{FF2B5EF4-FFF2-40B4-BE49-F238E27FC236}">
-                <a16:creationId xmlns:a16="http://schemas.microsoft.com/office/drawing/2014/main" id="{AC984606-D225-4872-ABD4-3A349055AF40}"/>
+                <a16:creationId xmlns:a16="http://schemas.microsoft.com/office/drawing/2014/main" id="{BD09172E-9A52-4B5B-905C-9625B4616CA0}"/>
               </a:ext>
             </a:extLst>
           </p:cNvPr>
@@ -8992,7 +8992,7 @@
           <p:cNvPr id="7" name="">
             <a:extLst xmlns:a="http://schemas.openxmlformats.org/drawingml/2006/main">
               <a:ext uri="{FF2B5EF4-FFF2-40B4-BE49-F238E27FC236}">
-                <a16:creationId xmlns:a16="http://schemas.microsoft.com/office/drawing/2014/main" id="{851F0DC6-7576-4F76-835A-5CB63494A823}"/>
+                <a16:creationId xmlns:a16="http://schemas.microsoft.com/office/drawing/2014/main" id="{81B93B66-B941-4551-8E2C-BB23B0C7E879}"/>
               </a:ext>
             </a:extLst>
           </p:cNvPr>
@@ -9060,7 +9060,7 @@
           <p:cNvPr id="8" name="">
             <a:extLst xmlns:a="http://schemas.openxmlformats.org/drawingml/2006/main">
               <a:ext uri="{FF2B5EF4-FFF2-40B4-BE49-F238E27FC236}">
-                <a16:creationId xmlns:a16="http://schemas.microsoft.com/office/drawing/2014/main" id="{2F733A81-2334-4220-A81D-756388DC3FC3}"/>
+                <a16:creationId xmlns:a16="http://schemas.microsoft.com/office/drawing/2014/main" id="{970FEC9E-5976-4CD8-94AC-6DDDCA06EF4C}"/>
               </a:ext>
             </a:extLst>
           </p:cNvPr>
@@ -9128,7 +9128,7 @@
           <p:cNvPr id="9" name="">
             <a:extLst xmlns:a="http://schemas.openxmlformats.org/drawingml/2006/main">
               <a:ext uri="{FF2B5EF4-FFF2-40B4-BE49-F238E27FC236}">
-                <a16:creationId xmlns:a16="http://schemas.microsoft.com/office/drawing/2014/main" id="{883780F3-B28C-4601-AADC-B4D98B45C4A4}"/>
+                <a16:creationId xmlns:a16="http://schemas.microsoft.com/office/drawing/2014/main" id="{C9C4569F-288B-4EFE-BAED-9C305DA17BCA}"/>
               </a:ext>
             </a:extLst>
           </p:cNvPr>
@@ -9196,7 +9196,7 @@
           <p:cNvPr id="10" name="">
             <a:extLst xmlns:a="http://schemas.openxmlformats.org/drawingml/2006/main">
               <a:ext uri="{FF2B5EF4-FFF2-40B4-BE49-F238E27FC236}">
-                <a16:creationId xmlns:a16="http://schemas.microsoft.com/office/drawing/2014/main" id="{94D79E08-312C-4A37-9D89-C05805116744}"/>
+                <a16:creationId xmlns:a16="http://schemas.microsoft.com/office/drawing/2014/main" id="{B5A8B935-6B91-4774-9078-4BECD5A67F47}"/>
               </a:ext>
             </a:extLst>
           </p:cNvPr>
@@ -9262,7 +9262,7 @@
     </p:spTree>
     <p:extLst>
       <p:ext uri="{BB962C8B-B14F-4D97-AF65-F5344CB8AC3E}">
-        <p14:creationId xmlns:p14="http://schemas.microsoft.com/office/powerpoint/2010/main" val="325542955"/>
+        <p14:creationId xmlns:p14="http://schemas.microsoft.com/office/powerpoint/2010/main" val="2108518170"/>
       </p:ext>
     </p:extLst>
   </p:cSld>
@@ -9293,7 +9293,7 @@
           <p:cNvPr id="5" name="">
             <a:extLst xmlns:a="http://schemas.openxmlformats.org/drawingml/2006/main">
               <a:ext uri="{FF2B5EF4-FFF2-40B4-BE49-F238E27FC236}">
-                <a16:creationId xmlns:a16="http://schemas.microsoft.com/office/drawing/2014/main" id="{3E4ADBB4-B666-4545-BA47-197D290A5A66}"/>
+                <a16:creationId xmlns:a16="http://schemas.microsoft.com/office/drawing/2014/main" id="{B6BC157B-8551-4BBD-9C67-E2D25C22B1D9}"/>
               </a:ext>
             </a:extLst>
           </p:cNvPr>
@@ -9361,7 +9361,7 @@
           <p:cNvPr id="2" name="">
             <a:extLst xmlns:a="http://schemas.openxmlformats.org/drawingml/2006/main">
               <a:ext uri="{FF2B5EF4-FFF2-40B4-BE49-F238E27FC236}">
-                <a16:creationId xmlns:a16="http://schemas.microsoft.com/office/drawing/2014/main" id="{06A1A017-16CC-42C3-ABBB-E82503906E25}"/>
+                <a16:creationId xmlns:a16="http://schemas.microsoft.com/office/drawing/2014/main" id="{1A0CD719-ADA4-449F-ACA5-25F36BD14852}"/>
               </a:ext>
             </a:extLst>
           </p:cNvPr>
@@ -9429,7 +9429,7 @@
           <p:cNvPr id="3" name="">
             <a:extLst xmlns:a="http://schemas.openxmlformats.org/drawingml/2006/main">
               <a:ext uri="{FF2B5EF4-FFF2-40B4-BE49-F238E27FC236}">
-                <a16:creationId xmlns:a16="http://schemas.microsoft.com/office/drawing/2014/main" id="{EB44A062-5103-45B4-8120-A24769405DB1}"/>
+                <a16:creationId xmlns:a16="http://schemas.microsoft.com/office/drawing/2014/main" id="{C202E731-28CC-4213-AB53-554B530FDEC2}"/>
               </a:ext>
             </a:extLst>
           </p:cNvPr>
@@ -9582,7 +9582,7 @@
           <p:cNvPr id="4" name="">
             <a:extLst xmlns:a="http://schemas.openxmlformats.org/drawingml/2006/main">
               <a:ext uri="{FF2B5EF4-FFF2-40B4-BE49-F238E27FC236}">
-                <a16:creationId xmlns:a16="http://schemas.microsoft.com/office/drawing/2014/main" id="{A328C03D-B751-4BE7-954E-590202CA3870}"/>
+                <a16:creationId xmlns:a16="http://schemas.microsoft.com/office/drawing/2014/main" id="{C64BBAAF-574A-4D63-B1C3-E72254D341C6}"/>
               </a:ext>
             </a:extLst>
           </p:cNvPr>
@@ -9648,7 +9648,7 @@
     </p:spTree>
     <p:extLst>
       <p:ext uri="{BB962C8B-B14F-4D97-AF65-F5344CB8AC3E}">
-        <p14:creationId xmlns:p14="http://schemas.microsoft.com/office/powerpoint/2010/main" val="416607813"/>
+        <p14:creationId xmlns:p14="http://schemas.microsoft.com/office/powerpoint/2010/main" val="1714913027"/>
       </p:ext>
     </p:extLst>
   </p:cSld>
@@ -9679,7 +9679,7 @@
           <p:cNvPr id="6" name="">
             <a:extLst xmlns:a="http://schemas.openxmlformats.org/drawingml/2006/main">
               <a:ext uri="{FF2B5EF4-FFF2-40B4-BE49-F238E27FC236}">
-                <a16:creationId xmlns:a16="http://schemas.microsoft.com/office/drawing/2014/main" id="{590CD01D-254B-43F3-848A-CB4641E2702C}"/>
+                <a16:creationId xmlns:a16="http://schemas.microsoft.com/office/drawing/2014/main" id="{CF08488C-91AF-4966-A24C-00C858109405}"/>
               </a:ext>
             </a:extLst>
           </p:cNvPr>
@@ -9747,7 +9747,7 @@
           <p:cNvPr id="2" name="">
             <a:extLst xmlns:a="http://schemas.openxmlformats.org/drawingml/2006/main">
               <a:ext uri="{FF2B5EF4-FFF2-40B4-BE49-F238E27FC236}">
-                <a16:creationId xmlns:a16="http://schemas.microsoft.com/office/drawing/2014/main" id="{6E61E3AA-D855-4FB6-A0C6-95E5FD3E90E1}"/>
+                <a16:creationId xmlns:a16="http://schemas.microsoft.com/office/drawing/2014/main" id="{A3632D24-B3AA-44EB-8FFA-39AD891B9981}"/>
               </a:ext>
             </a:extLst>
           </p:cNvPr>
@@ -9815,7 +9815,7 @@
           <p:cNvPr id="3" name="">
             <a:extLst xmlns:a="http://schemas.openxmlformats.org/drawingml/2006/main">
               <a:ext uri="{FF2B5EF4-FFF2-40B4-BE49-F238E27FC236}">
-                <a16:creationId xmlns:a16="http://schemas.microsoft.com/office/drawing/2014/main" id="{ED8C14F7-AAC7-4115-BE2C-B23D120DFC3E}"/>
+                <a16:creationId xmlns:a16="http://schemas.microsoft.com/office/drawing/2014/main" id="{87C15E6F-589C-47B5-81A7-25A4A7A1E697}"/>
               </a:ext>
             </a:extLst>
           </p:cNvPr>
@@ -10022,7 +10022,7 @@
           <p:cNvPr id="4" name="">
             <a:extLst xmlns:a="http://schemas.openxmlformats.org/drawingml/2006/main">
               <a:ext uri="{FF2B5EF4-FFF2-40B4-BE49-F238E27FC236}">
-                <a16:creationId xmlns:a16="http://schemas.microsoft.com/office/drawing/2014/main" id="{E1EC94EC-1F0E-4D0D-B780-3960D508E6D7}"/>
+                <a16:creationId xmlns:a16="http://schemas.microsoft.com/office/drawing/2014/main" id="{20115D7E-7994-44E5-A1C8-B840717CAFDA}"/>
               </a:ext>
             </a:extLst>
           </p:cNvPr>
@@ -10090,7 +10090,7 @@
           <p:cNvPr id="5" name="">
             <a:extLst xmlns:a="http://schemas.openxmlformats.org/drawingml/2006/main">
               <a:ext uri="{FF2B5EF4-FFF2-40B4-BE49-F238E27FC236}">
-                <a16:creationId xmlns:a16="http://schemas.microsoft.com/office/drawing/2014/main" id="{E066F3F8-87CA-4EF0-AD4E-8207338D4B4E}"/>
+                <a16:creationId xmlns:a16="http://schemas.microsoft.com/office/drawing/2014/main" id="{9CF8BC72-9751-4C7E-9CF4-88D5CCAC018B}"/>
               </a:ext>
             </a:extLst>
           </p:cNvPr>
@@ -10156,7 +10156,7 @@
     </p:spTree>
     <p:extLst>
       <p:ext uri="{BB962C8B-B14F-4D97-AF65-F5344CB8AC3E}">
-        <p14:creationId xmlns:p14="http://schemas.microsoft.com/office/powerpoint/2010/main" val="1704721627"/>
+        <p14:creationId xmlns:p14="http://schemas.microsoft.com/office/powerpoint/2010/main" val="1813522926"/>
       </p:ext>
     </p:extLst>
   </p:cSld>
@@ -10187,7 +10187,7 @@
           <p:cNvPr id="10" name="">
             <a:extLst xmlns:a="http://schemas.openxmlformats.org/drawingml/2006/main">
               <a:ext uri="{FF2B5EF4-FFF2-40B4-BE49-F238E27FC236}">
-                <a16:creationId xmlns:a16="http://schemas.microsoft.com/office/drawing/2014/main" id="{A60787F6-E272-43F9-B16B-9DC25B2C2B6B}"/>
+                <a16:creationId xmlns:a16="http://schemas.microsoft.com/office/drawing/2014/main" id="{D32D5B1D-A31F-4922-A7A4-083B11B0056F}"/>
               </a:ext>
             </a:extLst>
           </p:cNvPr>
@@ -10255,7 +10255,7 @@
           <p:cNvPr id="2" name="">
             <a:extLst xmlns:a="http://schemas.openxmlformats.org/drawingml/2006/main">
               <a:ext uri="{FF2B5EF4-FFF2-40B4-BE49-F238E27FC236}">
-                <a16:creationId xmlns:a16="http://schemas.microsoft.com/office/drawing/2014/main" id="{661B56B2-BCA0-4F34-9EC9-0BF131A6F753}"/>
+                <a16:creationId xmlns:a16="http://schemas.microsoft.com/office/drawing/2014/main" id="{BC7E7E1E-73EE-48B3-BFDD-E22D7FDE097D}"/>
               </a:ext>
             </a:extLst>
           </p:cNvPr>
@@ -10323,7 +10323,7 @@
           <p:cNvPr id="3" name="">
             <a:extLst xmlns:a="http://schemas.openxmlformats.org/drawingml/2006/main">
               <a:ext uri="{FF2B5EF4-FFF2-40B4-BE49-F238E27FC236}">
-                <a16:creationId xmlns:a16="http://schemas.microsoft.com/office/drawing/2014/main" id="{887EDC99-16B2-4945-B792-4645563C1883}"/>
+                <a16:creationId xmlns:a16="http://schemas.microsoft.com/office/drawing/2014/main" id="{E58654C5-4833-4DB4-8915-2162C0AB7DB9}"/>
               </a:ext>
             </a:extLst>
           </p:cNvPr>
@@ -10395,7 +10395,7 @@
           <p:cNvPr id="4" name="">
             <a:extLst xmlns:a="http://schemas.openxmlformats.org/drawingml/2006/main">
               <a:ext uri="{FF2B5EF4-FFF2-40B4-BE49-F238E27FC236}">
-                <a16:creationId xmlns:a16="http://schemas.microsoft.com/office/drawing/2014/main" id="{7605B22D-4C57-41F6-81ED-FFADCA45645A}"/>
+                <a16:creationId xmlns:a16="http://schemas.microsoft.com/office/drawing/2014/main" id="{76ADF8FE-2808-44A7-A9F0-33A7C32D42AE}"/>
               </a:ext>
             </a:extLst>
           </p:cNvPr>
@@ -10467,7 +10467,7 @@
           <p:cNvPr id="5" name="">
             <a:extLst xmlns:a="http://schemas.openxmlformats.org/drawingml/2006/main">
               <a:ext uri="{FF2B5EF4-FFF2-40B4-BE49-F238E27FC236}">
-                <a16:creationId xmlns:a16="http://schemas.microsoft.com/office/drawing/2014/main" id="{0D2DFCAA-2AC7-4A55-951B-CC2D3ED722B6}"/>
+                <a16:creationId xmlns:a16="http://schemas.microsoft.com/office/drawing/2014/main" id="{59325704-77DE-4C77-AC4B-7CC4183FD57D}"/>
               </a:ext>
             </a:extLst>
           </p:cNvPr>
@@ -10539,7 +10539,7 @@
           <p:cNvPr id="6" name="">
             <a:extLst xmlns:a="http://schemas.openxmlformats.org/drawingml/2006/main">
               <a:ext uri="{FF2B5EF4-FFF2-40B4-BE49-F238E27FC236}">
-                <a16:creationId xmlns:a16="http://schemas.microsoft.com/office/drawing/2014/main" id="{3BDD60DE-13F9-472B-B59D-5B0F943DE5E3}"/>
+                <a16:creationId xmlns:a16="http://schemas.microsoft.com/office/drawing/2014/main" id="{3EEBAFF5-FD2D-4C47-A55E-E9A6C0C4AE3E}"/>
               </a:ext>
             </a:extLst>
           </p:cNvPr>
@@ -10611,7 +10611,7 @@
           <p:cNvPr id="7" name="">
             <a:extLst xmlns:a="http://schemas.openxmlformats.org/drawingml/2006/main">
               <a:ext uri="{FF2B5EF4-FFF2-40B4-BE49-F238E27FC236}">
-                <a16:creationId xmlns:a16="http://schemas.microsoft.com/office/drawing/2014/main" id="{A6268732-B8C4-4256-AAB4-07139A659EB4}"/>
+                <a16:creationId xmlns:a16="http://schemas.microsoft.com/office/drawing/2014/main" id="{B1349E7F-434A-4F3E-912E-BFA9B0D567BA}"/>
               </a:ext>
             </a:extLst>
           </p:cNvPr>
@@ -10679,7 +10679,7 @@
           <p:cNvPr id="8" name="">
             <a:extLst xmlns:a="http://schemas.openxmlformats.org/drawingml/2006/main">
               <a:ext uri="{FF2B5EF4-FFF2-40B4-BE49-F238E27FC236}">
-                <a16:creationId xmlns:a16="http://schemas.microsoft.com/office/drawing/2014/main" id="{3E9B5F6B-4039-4081-882B-836CDAA6092D}"/>
+                <a16:creationId xmlns:a16="http://schemas.microsoft.com/office/drawing/2014/main" id="{4758D0EE-8860-4A82-AF2E-3CD7ED927938}"/>
               </a:ext>
             </a:extLst>
           </p:cNvPr>
@@ -10747,7 +10747,7 @@
           <p:cNvPr id="9" name="">
             <a:extLst xmlns:a="http://schemas.openxmlformats.org/drawingml/2006/main">
               <a:ext uri="{FF2B5EF4-FFF2-40B4-BE49-F238E27FC236}">
-                <a16:creationId xmlns:a16="http://schemas.microsoft.com/office/drawing/2014/main" id="{631E476F-2B3A-460F-9FAD-CC4659B0DFD2}"/>
+                <a16:creationId xmlns:a16="http://schemas.microsoft.com/office/drawing/2014/main" id="{619B9B33-6C58-46ED-8647-C771C30CEC69}"/>
               </a:ext>
             </a:extLst>
           </p:cNvPr>
@@ -10813,7 +10813,7 @@
     </p:spTree>
     <p:extLst>
       <p:ext uri="{BB962C8B-B14F-4D97-AF65-F5344CB8AC3E}">
-        <p14:creationId xmlns:p14="http://schemas.microsoft.com/office/powerpoint/2010/main" val="164573160"/>
+        <p14:creationId xmlns:p14="http://schemas.microsoft.com/office/powerpoint/2010/main" val="452979745"/>
       </p:ext>
     </p:extLst>
   </p:cSld>
@@ -10844,7 +10844,7 @@
           <p:cNvPr id="22" name="">
             <a:extLst xmlns:a="http://schemas.openxmlformats.org/drawingml/2006/main">
               <a:ext uri="{FF2B5EF4-FFF2-40B4-BE49-F238E27FC236}">
-                <a16:creationId xmlns:a16="http://schemas.microsoft.com/office/drawing/2014/main" id="{02EE8D6A-8F76-4A2D-A7C5-BB6EB0F6B23D}"/>
+                <a16:creationId xmlns:a16="http://schemas.microsoft.com/office/drawing/2014/main" id="{768DE4FE-7C2D-4254-B0AF-FA09FF8B2130}"/>
               </a:ext>
             </a:extLst>
           </p:cNvPr>
@@ -10912,7 +10912,7 @@
           <p:cNvPr id="2" name="">
             <a:extLst xmlns:a="http://schemas.openxmlformats.org/drawingml/2006/main">
               <a:ext uri="{FF2B5EF4-FFF2-40B4-BE49-F238E27FC236}">
-                <a16:creationId xmlns:a16="http://schemas.microsoft.com/office/drawing/2014/main" id="{D043481B-0FDF-48B9-B263-A10798272079}"/>
+                <a16:creationId xmlns:a16="http://schemas.microsoft.com/office/drawing/2014/main" id="{C88FA83C-9FD4-4610-ACF3-99FA20A5506F}"/>
               </a:ext>
             </a:extLst>
           </p:cNvPr>
@@ -10980,7 +10980,7 @@
           <p:cNvPr id="3" name="">
             <a:extLst xmlns:a="http://schemas.openxmlformats.org/drawingml/2006/main">
               <a:ext uri="{FF2B5EF4-FFF2-40B4-BE49-F238E27FC236}">
-                <a16:creationId xmlns:a16="http://schemas.microsoft.com/office/drawing/2014/main" id="{6CA16F9C-DB89-4D2E-BCF3-A4C75212C5A7}"/>
+                <a16:creationId xmlns:a16="http://schemas.microsoft.com/office/drawing/2014/main" id="{E38DC3EF-8C74-4AB3-A0BC-D30B17082554}"/>
               </a:ext>
             </a:extLst>
           </p:cNvPr>
@@ -11048,7 +11048,7 @@
           <p:cNvPr id="4" name="">
             <a:extLst xmlns:a="http://schemas.openxmlformats.org/drawingml/2006/main">
               <a:ext uri="{FF2B5EF4-FFF2-40B4-BE49-F238E27FC236}">
-                <a16:creationId xmlns:a16="http://schemas.microsoft.com/office/drawing/2014/main" id="{12ABE36E-5040-4065-AF64-D6D3E869D6FC}"/>
+                <a16:creationId xmlns:a16="http://schemas.microsoft.com/office/drawing/2014/main" id="{F37982C3-83D1-4E80-8A69-EB71D6E10A2C}"/>
               </a:ext>
             </a:extLst>
           </p:cNvPr>
@@ -11116,7 +11116,7 @@
           <p:cNvPr id="5" name="">
             <a:extLst xmlns:a="http://schemas.openxmlformats.org/drawingml/2006/main">
               <a:ext uri="{FF2B5EF4-FFF2-40B4-BE49-F238E27FC236}">
-                <a16:creationId xmlns:a16="http://schemas.microsoft.com/office/drawing/2014/main" id="{F3AFE62A-466C-4DF2-8591-3D96D3DEEC36}"/>
+                <a16:creationId xmlns:a16="http://schemas.microsoft.com/office/drawing/2014/main" id="{EA88BC1B-A931-4BC3-9815-36DFA5D8E3D5}"/>
               </a:ext>
             </a:extLst>
           </p:cNvPr>
@@ -11184,7 +11184,7 @@
           <p:cNvPr id="6" name="">
             <a:extLst xmlns:a="http://schemas.openxmlformats.org/drawingml/2006/main">
               <a:ext uri="{FF2B5EF4-FFF2-40B4-BE49-F238E27FC236}">
-                <a16:creationId xmlns:a16="http://schemas.microsoft.com/office/drawing/2014/main" id="{2E8CE26F-53A4-4FDB-83BF-3D309E980157}"/>
+                <a16:creationId xmlns:a16="http://schemas.microsoft.com/office/drawing/2014/main" id="{3EC41D7B-8071-4C5D-AC67-C50C62C4E4B6}"/>
               </a:ext>
             </a:extLst>
           </p:cNvPr>
@@ -11252,7 +11252,7 @@
           <p:cNvPr id="7" name="">
             <a:extLst xmlns:a="http://schemas.openxmlformats.org/drawingml/2006/main">
               <a:ext uri="{FF2B5EF4-FFF2-40B4-BE49-F238E27FC236}">
-                <a16:creationId xmlns:a16="http://schemas.microsoft.com/office/drawing/2014/main" id="{50331123-1973-4F2D-94A6-9C111CF96AA1}"/>
+                <a16:creationId xmlns:a16="http://schemas.microsoft.com/office/drawing/2014/main" id="{A8D47DE6-53FC-4507-896F-3B2C5F88C0C7}"/>
               </a:ext>
             </a:extLst>
           </p:cNvPr>
@@ -11320,7 +11320,7 @@
           <p:cNvPr id="8" name="">
             <a:extLst xmlns:a="http://schemas.openxmlformats.org/drawingml/2006/main">
               <a:ext uri="{FF2B5EF4-FFF2-40B4-BE49-F238E27FC236}">
-                <a16:creationId xmlns:a16="http://schemas.microsoft.com/office/drawing/2014/main" id="{0C224886-8919-41E5-B863-63A2E184436C}"/>
+                <a16:creationId xmlns:a16="http://schemas.microsoft.com/office/drawing/2014/main" id="{85599853-BD23-49B2-85A5-0D737A85E8F2}"/>
               </a:ext>
             </a:extLst>
           </p:cNvPr>
@@ -11388,7 +11388,7 @@
           <p:cNvPr id="9" name="">
             <a:extLst xmlns:a="http://schemas.openxmlformats.org/drawingml/2006/main">
               <a:ext uri="{FF2B5EF4-FFF2-40B4-BE49-F238E27FC236}">
-                <a16:creationId xmlns:a16="http://schemas.microsoft.com/office/drawing/2014/main" id="{C46043AE-95A9-4A0C-93CF-F19F070411C4}"/>
+                <a16:creationId xmlns:a16="http://schemas.microsoft.com/office/drawing/2014/main" id="{BA122C42-FEC8-48DD-AEA1-4431F70C34E7}"/>
               </a:ext>
             </a:extLst>
           </p:cNvPr>
@@ -11456,7 +11456,7 @@
           <p:cNvPr id="10" name="">
             <a:extLst xmlns:a="http://schemas.openxmlformats.org/drawingml/2006/main">
               <a:ext uri="{FF2B5EF4-FFF2-40B4-BE49-F238E27FC236}">
-                <a16:creationId xmlns:a16="http://schemas.microsoft.com/office/drawing/2014/main" id="{9F78CF3D-787B-4087-8764-6E2D71847293}"/>
+                <a16:creationId xmlns:a16="http://schemas.microsoft.com/office/drawing/2014/main" id="{086CAC2F-5E2A-4191-8451-DBF47F0A4120}"/>
               </a:ext>
             </a:extLst>
           </p:cNvPr>
@@ -11524,7 +11524,7 @@
           <p:cNvPr id="11" name="">
             <a:extLst xmlns:a="http://schemas.openxmlformats.org/drawingml/2006/main">
               <a:ext uri="{FF2B5EF4-FFF2-40B4-BE49-F238E27FC236}">
-                <a16:creationId xmlns:a16="http://schemas.microsoft.com/office/drawing/2014/main" id="{47AECD9F-9AE7-4FA8-A02B-0FDF5189936E}"/>
+                <a16:creationId xmlns:a16="http://schemas.microsoft.com/office/drawing/2014/main" id="{11B2D8DC-1762-4F79-B987-AE481C8CA7D2}"/>
               </a:ext>
             </a:extLst>
           </p:cNvPr>
@@ -11592,7 +11592,7 @@
           <p:cNvPr id="12" name="">
             <a:extLst xmlns:a="http://schemas.openxmlformats.org/drawingml/2006/main">
               <a:ext uri="{FF2B5EF4-FFF2-40B4-BE49-F238E27FC236}">
-                <a16:creationId xmlns:a16="http://schemas.microsoft.com/office/drawing/2014/main" id="{FE68AE42-F17E-4546-B47B-4A3CB163643E}"/>
+                <a16:creationId xmlns:a16="http://schemas.microsoft.com/office/drawing/2014/main" id="{FD00773C-FF5B-427E-9ECD-51FD72EAE652}"/>
               </a:ext>
             </a:extLst>
           </p:cNvPr>
@@ -11660,7 +11660,7 @@
           <p:cNvPr id="13" name="">
             <a:extLst xmlns:a="http://schemas.openxmlformats.org/drawingml/2006/main">
               <a:ext uri="{FF2B5EF4-FFF2-40B4-BE49-F238E27FC236}">
-                <a16:creationId xmlns:a16="http://schemas.microsoft.com/office/drawing/2014/main" id="{AC518018-C57F-44F0-BE65-1C43859D3484}"/>
+                <a16:creationId xmlns:a16="http://schemas.microsoft.com/office/drawing/2014/main" id="{7A2932CD-8AB1-4FCA-B6F1-045393BFF51B}"/>
               </a:ext>
             </a:extLst>
           </p:cNvPr>
@@ -11728,7 +11728,7 @@
           <p:cNvPr id="14" name="">
             <a:extLst xmlns:a="http://schemas.openxmlformats.org/drawingml/2006/main">
               <a:ext uri="{FF2B5EF4-FFF2-40B4-BE49-F238E27FC236}">
-                <a16:creationId xmlns:a16="http://schemas.microsoft.com/office/drawing/2014/main" id="{C018A11E-568A-4F10-9D69-AE8B05386C7A}"/>
+                <a16:creationId xmlns:a16="http://schemas.microsoft.com/office/drawing/2014/main" id="{355E81AD-FD24-4184-B460-3F03F8C252D2}"/>
               </a:ext>
             </a:extLst>
           </p:cNvPr>
@@ -11796,7 +11796,7 @@
           <p:cNvPr id="15" name="">
             <a:extLst xmlns:a="http://schemas.openxmlformats.org/drawingml/2006/main">
               <a:ext uri="{FF2B5EF4-FFF2-40B4-BE49-F238E27FC236}">
-                <a16:creationId xmlns:a16="http://schemas.microsoft.com/office/drawing/2014/main" id="{51E0CFE7-6B48-4983-9684-8A4F11F2DAD1}"/>
+                <a16:creationId xmlns:a16="http://schemas.microsoft.com/office/drawing/2014/main" id="{80F29FF5-464E-4DA4-8E16-FD4C4D958EA9}"/>
               </a:ext>
             </a:extLst>
           </p:cNvPr>
@@ -11864,7 +11864,7 @@
           <p:cNvPr id="16" name="">
             <a:extLst xmlns:a="http://schemas.openxmlformats.org/drawingml/2006/main">
               <a:ext uri="{FF2B5EF4-FFF2-40B4-BE49-F238E27FC236}">
-                <a16:creationId xmlns:a16="http://schemas.microsoft.com/office/drawing/2014/main" id="{88232ACD-B9EC-4DBE-B4DA-E86AC9E37735}"/>
+                <a16:creationId xmlns:a16="http://schemas.microsoft.com/office/drawing/2014/main" id="{A1EE431C-C3C7-4BAB-B50C-99F1DA4A1088}"/>
               </a:ext>
             </a:extLst>
           </p:cNvPr>
@@ -11932,7 +11932,7 @@
           <p:cNvPr id="17" name="">
             <a:extLst xmlns:a="http://schemas.openxmlformats.org/drawingml/2006/main">
               <a:ext uri="{FF2B5EF4-FFF2-40B4-BE49-F238E27FC236}">
-                <a16:creationId xmlns:a16="http://schemas.microsoft.com/office/drawing/2014/main" id="{1A04C84B-5829-4786-B036-8F30F7B449A9}"/>
+                <a16:creationId xmlns:a16="http://schemas.microsoft.com/office/drawing/2014/main" id="{3C257B2B-6E08-4739-8DAC-F002D4F2EB51}"/>
               </a:ext>
             </a:extLst>
           </p:cNvPr>
@@ -12000,7 +12000,7 @@
           <p:cNvPr id="18" name="">
             <a:extLst xmlns:a="http://schemas.openxmlformats.org/drawingml/2006/main">
               <a:ext uri="{FF2B5EF4-FFF2-40B4-BE49-F238E27FC236}">
-                <a16:creationId xmlns:a16="http://schemas.microsoft.com/office/drawing/2014/main" id="{CDDB760C-7F77-4B1F-AD89-A4D4DA347635}"/>
+                <a16:creationId xmlns:a16="http://schemas.microsoft.com/office/drawing/2014/main" id="{7E411AE6-8909-47D5-9241-162B66D9CC48}"/>
               </a:ext>
             </a:extLst>
           </p:cNvPr>
@@ -12068,7 +12068,7 @@
           <p:cNvPr id="19" name="">
             <a:extLst xmlns:a="http://schemas.openxmlformats.org/drawingml/2006/main">
               <a:ext uri="{FF2B5EF4-FFF2-40B4-BE49-F238E27FC236}">
-                <a16:creationId xmlns:a16="http://schemas.microsoft.com/office/drawing/2014/main" id="{4B0C6089-A05B-4B7B-BD03-8E92A435EAC7}"/>
+                <a16:creationId xmlns:a16="http://schemas.microsoft.com/office/drawing/2014/main" id="{B591536C-EBD9-4D15-99DA-28B6347F195F}"/>
               </a:ext>
             </a:extLst>
           </p:cNvPr>
@@ -12136,7 +12136,7 @@
           <p:cNvPr id="20" name="">
             <a:extLst xmlns:a="http://schemas.openxmlformats.org/drawingml/2006/main">
               <a:ext uri="{FF2B5EF4-FFF2-40B4-BE49-F238E27FC236}">
-                <a16:creationId xmlns:a16="http://schemas.microsoft.com/office/drawing/2014/main" id="{6648D1E1-4058-4AB8-B94C-605804391BE2}"/>
+                <a16:creationId xmlns:a16="http://schemas.microsoft.com/office/drawing/2014/main" id="{8E1CB974-3E6C-4352-BB2F-A7FEC23E13FA}"/>
               </a:ext>
             </a:extLst>
           </p:cNvPr>
@@ -12204,7 +12204,7 @@
           <p:cNvPr id="21" name="">
             <a:extLst xmlns:a="http://schemas.openxmlformats.org/drawingml/2006/main">
               <a:ext uri="{FF2B5EF4-FFF2-40B4-BE49-F238E27FC236}">
-                <a16:creationId xmlns:a16="http://schemas.microsoft.com/office/drawing/2014/main" id="{FB8B3DD0-B0E9-4102-8F67-4BB5BDCED477}"/>
+                <a16:creationId xmlns:a16="http://schemas.microsoft.com/office/drawing/2014/main" id="{7AEF69D3-93C0-4F0C-A875-D79C17B12EB8}"/>
               </a:ext>
             </a:extLst>
           </p:cNvPr>
@@ -12270,7 +12270,7 @@
     </p:spTree>
     <p:extLst>
       <p:ext uri="{BB962C8B-B14F-4D97-AF65-F5344CB8AC3E}">
-        <p14:creationId xmlns:p14="http://schemas.microsoft.com/office/powerpoint/2010/main" val="2046001974"/>
+        <p14:creationId xmlns:p14="http://schemas.microsoft.com/office/powerpoint/2010/main" val="40317393"/>
       </p:ext>
     </p:extLst>
   </p:cSld>
@@ -12301,7 +12301,7 @@
           <p:cNvPr id="12" name="">
             <a:extLst xmlns:a="http://schemas.openxmlformats.org/drawingml/2006/main">
               <a:ext uri="{FF2B5EF4-FFF2-40B4-BE49-F238E27FC236}">
-                <a16:creationId xmlns:a16="http://schemas.microsoft.com/office/drawing/2014/main" id="{14CA4A03-A232-4971-898C-CD56F270AC5B}"/>
+                <a16:creationId xmlns:a16="http://schemas.microsoft.com/office/drawing/2014/main" id="{7E767170-DE30-4312-A45E-6737E86227EA}"/>
               </a:ext>
             </a:extLst>
           </p:cNvPr>
@@ -12369,7 +12369,7 @@
           <p:cNvPr id="2" name="">
             <a:extLst xmlns:a="http://schemas.openxmlformats.org/drawingml/2006/main">
               <a:ext uri="{FF2B5EF4-FFF2-40B4-BE49-F238E27FC236}">
-                <a16:creationId xmlns:a16="http://schemas.microsoft.com/office/drawing/2014/main" id="{5C3532F8-48B6-4C09-BF1B-AFED71F02492}"/>
+                <a16:creationId xmlns:a16="http://schemas.microsoft.com/office/drawing/2014/main" id="{FC6861A4-1867-434A-A94E-50248DFB4216}"/>
               </a:ext>
             </a:extLst>
           </p:cNvPr>
@@ -12437,7 +12437,7 @@
           <p:cNvPr id="3" name="">
             <a:extLst xmlns:a="http://schemas.openxmlformats.org/drawingml/2006/main">
               <a:ext uri="{FF2B5EF4-FFF2-40B4-BE49-F238E27FC236}">
-                <a16:creationId xmlns:a16="http://schemas.microsoft.com/office/drawing/2014/main" id="{93C8E041-DFAC-4E0F-BB62-28B670683039}"/>
+                <a16:creationId xmlns:a16="http://schemas.microsoft.com/office/drawing/2014/main" id="{850FEA73-7BB6-4C28-B55B-044B7AD2AC6B}"/>
               </a:ext>
             </a:extLst>
           </p:cNvPr>
@@ -12505,7 +12505,7 @@
           <p:cNvPr id="4" name="">
             <a:extLst xmlns:a="http://schemas.openxmlformats.org/drawingml/2006/main">
               <a:ext uri="{FF2B5EF4-FFF2-40B4-BE49-F238E27FC236}">
-                <a16:creationId xmlns:a16="http://schemas.microsoft.com/office/drawing/2014/main" id="{3C25947D-9269-4568-8E1E-3CF88F5186AD}"/>
+                <a16:creationId xmlns:a16="http://schemas.microsoft.com/office/drawing/2014/main" id="{AC60E773-F953-4DDA-AF27-6839108A17B2}"/>
               </a:ext>
             </a:extLst>
           </p:cNvPr>
@@ -12573,7 +12573,7 @@
           <p:cNvPr id="5" name="">
             <a:extLst xmlns:a="http://schemas.openxmlformats.org/drawingml/2006/main">
               <a:ext uri="{FF2B5EF4-FFF2-40B4-BE49-F238E27FC236}">
-                <a16:creationId xmlns:a16="http://schemas.microsoft.com/office/drawing/2014/main" id="{85501E6E-D38E-4BE4-8BD2-D5EA13D7080E}"/>
+                <a16:creationId xmlns:a16="http://schemas.microsoft.com/office/drawing/2014/main" id="{1D91329B-7124-4D9E-997B-008F72CEE6CE}"/>
               </a:ext>
             </a:extLst>
           </p:cNvPr>
@@ -12641,7 +12641,7 @@
           <p:cNvPr id="6" name="">
             <a:extLst xmlns:a="http://schemas.openxmlformats.org/drawingml/2006/main">
               <a:ext uri="{FF2B5EF4-FFF2-40B4-BE49-F238E27FC236}">
-                <a16:creationId xmlns:a16="http://schemas.microsoft.com/office/drawing/2014/main" id="{348A6EAC-8407-438B-9792-294C2BFB9C25}"/>
+                <a16:creationId xmlns:a16="http://schemas.microsoft.com/office/drawing/2014/main" id="{D388CC01-9C48-4AC4-9998-17893874B39E}"/>
               </a:ext>
             </a:extLst>
           </p:cNvPr>
@@ -12709,7 +12709,7 @@
           <p:cNvPr id="7" name="">
             <a:extLst xmlns:a="http://schemas.openxmlformats.org/drawingml/2006/main">
               <a:ext uri="{FF2B5EF4-FFF2-40B4-BE49-F238E27FC236}">
-                <a16:creationId xmlns:a16="http://schemas.microsoft.com/office/drawing/2014/main" id="{ECB2D717-9DC3-47CD-A0C3-E4D48690CEA6}"/>
+                <a16:creationId xmlns:a16="http://schemas.microsoft.com/office/drawing/2014/main" id="{1562701F-215E-426A-9B2E-B38B0E8442F5}"/>
               </a:ext>
             </a:extLst>
           </p:cNvPr>
@@ -12777,7 +12777,7 @@
           <p:cNvPr id="8" name="">
             <a:extLst xmlns:a="http://schemas.openxmlformats.org/drawingml/2006/main">
               <a:ext uri="{FF2B5EF4-FFF2-40B4-BE49-F238E27FC236}">
-                <a16:creationId xmlns:a16="http://schemas.microsoft.com/office/drawing/2014/main" id="{67A9094B-6B6E-4C78-86FD-E40482B69199}"/>
+                <a16:creationId xmlns:a16="http://schemas.microsoft.com/office/drawing/2014/main" id="{327F3DBD-D308-4169-A2A3-55C72CC83AC3}"/>
               </a:ext>
             </a:extLst>
           </p:cNvPr>
@@ -12845,7 +12845,7 @@
           <p:cNvPr id="9" name="">
             <a:extLst xmlns:a="http://schemas.openxmlformats.org/drawingml/2006/main">
               <a:ext uri="{FF2B5EF4-FFF2-40B4-BE49-F238E27FC236}">
-                <a16:creationId xmlns:a16="http://schemas.microsoft.com/office/drawing/2014/main" id="{91DB569E-66D1-4D1F-99A5-39A7673E069B}"/>
+                <a16:creationId xmlns:a16="http://schemas.microsoft.com/office/drawing/2014/main" id="{B37838AD-FFAB-4FA1-AD5E-7056C0005142}"/>
               </a:ext>
             </a:extLst>
           </p:cNvPr>
@@ -12913,7 +12913,7 @@
           <p:cNvPr id="10" name="">
             <a:extLst xmlns:a="http://schemas.openxmlformats.org/drawingml/2006/main">
               <a:ext uri="{FF2B5EF4-FFF2-40B4-BE49-F238E27FC236}">
-                <a16:creationId xmlns:a16="http://schemas.microsoft.com/office/drawing/2014/main" id="{D967D965-5BBE-495A-AD95-C32A2684B46D}"/>
+                <a16:creationId xmlns:a16="http://schemas.microsoft.com/office/drawing/2014/main" id="{BAAAE547-F436-4A00-9A2E-965A79BF6383}"/>
               </a:ext>
             </a:extLst>
           </p:cNvPr>
@@ -12981,7 +12981,7 @@
           <p:cNvPr id="11" name="">
             <a:extLst xmlns:a="http://schemas.openxmlformats.org/drawingml/2006/main">
               <a:ext uri="{FF2B5EF4-FFF2-40B4-BE49-F238E27FC236}">
-                <a16:creationId xmlns:a16="http://schemas.microsoft.com/office/drawing/2014/main" id="{454589A6-6835-4F77-A37B-682FFDAD681F}"/>
+                <a16:creationId xmlns:a16="http://schemas.microsoft.com/office/drawing/2014/main" id="{CAA04511-91C7-4721-82F6-449E56CE1B04}"/>
               </a:ext>
             </a:extLst>
           </p:cNvPr>
@@ -13047,7 +13047,7 @@
     </p:spTree>
     <p:extLst>
       <p:ext uri="{BB962C8B-B14F-4D97-AF65-F5344CB8AC3E}">
-        <p14:creationId xmlns:p14="http://schemas.microsoft.com/office/powerpoint/2010/main" val="1738675991"/>
+        <p14:creationId xmlns:p14="http://schemas.microsoft.com/office/powerpoint/2010/main" val="1687070244"/>
       </p:ext>
     </p:extLst>
   </p:cSld>
@@ -13078,7 +13078,7 @@
           <p:cNvPr id="17" name="">
             <a:extLst xmlns:a="http://schemas.openxmlformats.org/drawingml/2006/main">
               <a:ext uri="{FF2B5EF4-FFF2-40B4-BE49-F238E27FC236}">
-                <a16:creationId xmlns:a16="http://schemas.microsoft.com/office/drawing/2014/main" id="{1433FE4E-EB35-42E4-A49A-3F8818730531}"/>
+                <a16:creationId xmlns:a16="http://schemas.microsoft.com/office/drawing/2014/main" id="{94BCE5C6-2C67-4408-AD44-98176D003CBA}"/>
               </a:ext>
             </a:extLst>
           </p:cNvPr>
@@ -13146,7 +13146,7 @@
           <p:cNvPr id="2" name="">
             <a:extLst xmlns:a="http://schemas.openxmlformats.org/drawingml/2006/main">
               <a:ext uri="{FF2B5EF4-FFF2-40B4-BE49-F238E27FC236}">
-                <a16:creationId xmlns:a16="http://schemas.microsoft.com/office/drawing/2014/main" id="{19B3FB12-3C9F-41C2-89FA-27DF55550925}"/>
+                <a16:creationId xmlns:a16="http://schemas.microsoft.com/office/drawing/2014/main" id="{89C74F85-7762-4CC9-B9BB-2ACC07AC1C7A}"/>
               </a:ext>
             </a:extLst>
           </p:cNvPr>
@@ -13214,7 +13214,7 @@
           <p:cNvPr id="3" name="">
             <a:extLst xmlns:a="http://schemas.openxmlformats.org/drawingml/2006/main">
               <a:ext uri="{FF2B5EF4-FFF2-40B4-BE49-F238E27FC236}">
-                <a16:creationId xmlns:a16="http://schemas.microsoft.com/office/drawing/2014/main" id="{8B672A9C-D8FB-433B-9485-69E305B59730}"/>
+                <a16:creationId xmlns:a16="http://schemas.microsoft.com/office/drawing/2014/main" id="{2F75A99D-C5E4-48BD-BC1A-7D08699CD2FB}"/>
               </a:ext>
             </a:extLst>
           </p:cNvPr>
@@ -13282,7 +13282,7 @@
           <p:cNvPr id="4" name="">
             <a:extLst xmlns:a="http://schemas.openxmlformats.org/drawingml/2006/main">
               <a:ext uri="{FF2B5EF4-FFF2-40B4-BE49-F238E27FC236}">
-                <a16:creationId xmlns:a16="http://schemas.microsoft.com/office/drawing/2014/main" id="{8199CDB8-798B-4188-B014-7AF6C599F720}"/>
+                <a16:creationId xmlns:a16="http://schemas.microsoft.com/office/drawing/2014/main" id="{47537079-2FE3-4B82-B26E-F13950138A3C}"/>
               </a:ext>
             </a:extLst>
           </p:cNvPr>
@@ -13350,7 +13350,7 @@
           <p:cNvPr id="5" name="">
             <a:extLst xmlns:a="http://schemas.openxmlformats.org/drawingml/2006/main">
               <a:ext uri="{FF2B5EF4-FFF2-40B4-BE49-F238E27FC236}">
-                <a16:creationId xmlns:a16="http://schemas.microsoft.com/office/drawing/2014/main" id="{CD967C59-0003-4F30-92FC-CFB8124EAEC7}"/>
+                <a16:creationId xmlns:a16="http://schemas.microsoft.com/office/drawing/2014/main" id="{98F21256-9833-41E6-A376-B199AFC27ADF}"/>
               </a:ext>
             </a:extLst>
           </p:cNvPr>
@@ -13418,7 +13418,7 @@
           <p:cNvPr id="6" name="">
             <a:extLst xmlns:a="http://schemas.openxmlformats.org/drawingml/2006/main">
               <a:ext uri="{FF2B5EF4-FFF2-40B4-BE49-F238E27FC236}">
-                <a16:creationId xmlns:a16="http://schemas.microsoft.com/office/drawing/2014/main" id="{34CB3734-CD5D-47F2-9AE0-C24B65462616}"/>
+                <a16:creationId xmlns:a16="http://schemas.microsoft.com/office/drawing/2014/main" id="{FE2D14EF-097E-4308-AFBD-F784C74DE63D}"/>
               </a:ext>
             </a:extLst>
           </p:cNvPr>
@@ -13486,7 +13486,7 @@
           <p:cNvPr id="7" name="">
             <a:extLst xmlns:a="http://schemas.openxmlformats.org/drawingml/2006/main">
               <a:ext uri="{FF2B5EF4-FFF2-40B4-BE49-F238E27FC236}">
-                <a16:creationId xmlns:a16="http://schemas.microsoft.com/office/drawing/2014/main" id="{8E0241ED-85A1-4C84-95A1-7B5B6D4E401C}"/>
+                <a16:creationId xmlns:a16="http://schemas.microsoft.com/office/drawing/2014/main" id="{77E53F19-208A-44FD-A73F-4E8431079761}"/>
               </a:ext>
             </a:extLst>
           </p:cNvPr>
@@ -13554,7 +13554,7 @@
           <p:cNvPr id="8" name="">
             <a:extLst xmlns:a="http://schemas.openxmlformats.org/drawingml/2006/main">
               <a:ext uri="{FF2B5EF4-FFF2-40B4-BE49-F238E27FC236}">
-                <a16:creationId xmlns:a16="http://schemas.microsoft.com/office/drawing/2014/main" id="{8C48AF8A-8094-4F26-9776-778374DE29D0}"/>
+                <a16:creationId xmlns:a16="http://schemas.microsoft.com/office/drawing/2014/main" id="{6E8B5431-4751-4125-892F-4BC5D7EC1F26}"/>
               </a:ext>
             </a:extLst>
           </p:cNvPr>
@@ -13622,7 +13622,7 @@
           <p:cNvPr id="9" name="">
             <a:extLst xmlns:a="http://schemas.openxmlformats.org/drawingml/2006/main">
               <a:ext uri="{FF2B5EF4-FFF2-40B4-BE49-F238E27FC236}">
-                <a16:creationId xmlns:a16="http://schemas.microsoft.com/office/drawing/2014/main" id="{552A786E-4C6F-4994-9B0B-694BAE7E25F6}"/>
+                <a16:creationId xmlns:a16="http://schemas.microsoft.com/office/drawing/2014/main" id="{C09E65F3-B561-480C-AF8D-F94AC210DB12}"/>
               </a:ext>
             </a:extLst>
           </p:cNvPr>
@@ -13690,7 +13690,7 @@
           <p:cNvPr id="10" name="">
             <a:extLst xmlns:a="http://schemas.openxmlformats.org/drawingml/2006/main">
               <a:ext uri="{FF2B5EF4-FFF2-40B4-BE49-F238E27FC236}">
-                <a16:creationId xmlns:a16="http://schemas.microsoft.com/office/drawing/2014/main" id="{77A04F7C-ADBC-4D50-B80F-C4310BC0F181}"/>
+                <a16:creationId xmlns:a16="http://schemas.microsoft.com/office/drawing/2014/main" id="{67560E20-E5F0-4589-90C5-0819255A12B1}"/>
               </a:ext>
             </a:extLst>
           </p:cNvPr>
@@ -13758,7 +13758,7 @@
           <p:cNvPr id="11" name="">
             <a:extLst xmlns:a="http://schemas.openxmlformats.org/drawingml/2006/main">
               <a:ext uri="{FF2B5EF4-FFF2-40B4-BE49-F238E27FC236}">
-                <a16:creationId xmlns:a16="http://schemas.microsoft.com/office/drawing/2014/main" id="{009709D6-BBB5-482B-87AA-15E0A34B314C}"/>
+                <a16:creationId xmlns:a16="http://schemas.microsoft.com/office/drawing/2014/main" id="{5E7BDE43-A6A6-4841-8394-99974A83EE87}"/>
               </a:ext>
             </a:extLst>
           </p:cNvPr>
@@ -13826,7 +13826,7 @@
           <p:cNvPr id="12" name="">
             <a:extLst xmlns:a="http://schemas.openxmlformats.org/drawingml/2006/main">
               <a:ext uri="{FF2B5EF4-FFF2-40B4-BE49-F238E27FC236}">
-                <a16:creationId xmlns:a16="http://schemas.microsoft.com/office/drawing/2014/main" id="{A34946E8-5776-4DC9-AA03-078312A9D698}"/>
+                <a16:creationId xmlns:a16="http://schemas.microsoft.com/office/drawing/2014/main" id="{54C6F11F-B261-4094-A49F-0C9374DB7B82}"/>
               </a:ext>
             </a:extLst>
           </p:cNvPr>
@@ -13894,7 +13894,7 @@
           <p:cNvPr id="13" name="">
             <a:extLst xmlns:a="http://schemas.openxmlformats.org/drawingml/2006/main">
               <a:ext uri="{FF2B5EF4-FFF2-40B4-BE49-F238E27FC236}">
-                <a16:creationId xmlns:a16="http://schemas.microsoft.com/office/drawing/2014/main" id="{778AAB18-D7F8-4BFE-A3DF-B5601A8B2F3F}"/>
+                <a16:creationId xmlns:a16="http://schemas.microsoft.com/office/drawing/2014/main" id="{B1BC1BFD-0118-4ABE-B573-737857C271C8}"/>
               </a:ext>
             </a:extLst>
           </p:cNvPr>
@@ -13962,7 +13962,7 @@
           <p:cNvPr id="14" name="">
             <a:extLst xmlns:a="http://schemas.openxmlformats.org/drawingml/2006/main">
               <a:ext uri="{FF2B5EF4-FFF2-40B4-BE49-F238E27FC236}">
-                <a16:creationId xmlns:a16="http://schemas.microsoft.com/office/drawing/2014/main" id="{60435BD9-ADCB-434B-B4AE-DB1E46AE8BF3}"/>
+                <a16:creationId xmlns:a16="http://schemas.microsoft.com/office/drawing/2014/main" id="{9E795B0D-F9BF-4BD8-8ABD-B76CA509EDB4}"/>
               </a:ext>
             </a:extLst>
           </p:cNvPr>
@@ -14030,7 +14030,7 @@
           <p:cNvPr id="15" name="">
             <a:extLst xmlns:a="http://schemas.openxmlformats.org/drawingml/2006/main">
               <a:ext uri="{FF2B5EF4-FFF2-40B4-BE49-F238E27FC236}">
-                <a16:creationId xmlns:a16="http://schemas.microsoft.com/office/drawing/2014/main" id="{AE2CB996-237B-46FD-96DB-BFA2DFDCD64C}"/>
+                <a16:creationId xmlns:a16="http://schemas.microsoft.com/office/drawing/2014/main" id="{70F1AD57-BA7C-4467-B1BF-0656CC098317}"/>
               </a:ext>
             </a:extLst>
           </p:cNvPr>
@@ -14098,7 +14098,7 @@
           <p:cNvPr id="16" name="">
             <a:extLst xmlns:a="http://schemas.openxmlformats.org/drawingml/2006/main">
               <a:ext uri="{FF2B5EF4-FFF2-40B4-BE49-F238E27FC236}">
-                <a16:creationId xmlns:a16="http://schemas.microsoft.com/office/drawing/2014/main" id="{A935CD68-3D00-4400-9F9C-1791CCD3730A}"/>
+                <a16:creationId xmlns:a16="http://schemas.microsoft.com/office/drawing/2014/main" id="{C00631A5-3024-4412-964C-9B8E18550D82}"/>
               </a:ext>
             </a:extLst>
           </p:cNvPr>
@@ -14164,7 +14164,7 @@
     </p:spTree>
     <p:extLst>
       <p:ext uri="{BB962C8B-B14F-4D97-AF65-F5344CB8AC3E}">
-        <p14:creationId xmlns:p14="http://schemas.microsoft.com/office/powerpoint/2010/main" val="84776002"/>
+        <p14:creationId xmlns:p14="http://schemas.microsoft.com/office/powerpoint/2010/main" val="169454588"/>
       </p:ext>
     </p:extLst>
   </p:cSld>
@@ -14195,7 +14195,7 @@
           <p:cNvPr id="5" name="">
             <a:extLst xmlns:a="http://schemas.openxmlformats.org/drawingml/2006/main">
               <a:ext uri="{FF2B5EF4-FFF2-40B4-BE49-F238E27FC236}">
-                <a16:creationId xmlns:a16="http://schemas.microsoft.com/office/drawing/2014/main" id="{65BCC669-8C5B-4370-8269-5BBB1D6BC0F9}"/>
+                <a16:creationId xmlns:a16="http://schemas.microsoft.com/office/drawing/2014/main" id="{408C42E6-56A0-4763-B26D-8284D63569A8}"/>
               </a:ext>
             </a:extLst>
           </p:cNvPr>
@@ -14263,7 +14263,7 @@
           <p:cNvPr id="2" name="">
             <a:extLst xmlns:a="http://schemas.openxmlformats.org/drawingml/2006/main">
               <a:ext uri="{FF2B5EF4-FFF2-40B4-BE49-F238E27FC236}">
-                <a16:creationId xmlns:a16="http://schemas.microsoft.com/office/drawing/2014/main" id="{3AA1DFDB-21FC-4488-A28E-777E29E932FB}"/>
+                <a16:creationId xmlns:a16="http://schemas.microsoft.com/office/drawing/2014/main" id="{A8E34257-4764-41C4-A663-5034287684A7}"/>
               </a:ext>
             </a:extLst>
           </p:cNvPr>
@@ -14331,7 +14331,7 @@
           <p:cNvPr id="3" name="">
             <a:extLst xmlns:a="http://schemas.openxmlformats.org/drawingml/2006/main">
               <a:ext uri="{FF2B5EF4-FFF2-40B4-BE49-F238E27FC236}">
-                <a16:creationId xmlns:a16="http://schemas.microsoft.com/office/drawing/2014/main" id="{51A9A3F7-3FCC-457E-8F33-D62D96B941DB}"/>
+                <a16:creationId xmlns:a16="http://schemas.microsoft.com/office/drawing/2014/main" id="{C243D435-A682-42E3-AF05-F41C86DA0C9C}"/>
               </a:ext>
             </a:extLst>
           </p:cNvPr>
@@ -14511,7 +14511,7 @@
           <p:cNvPr id="4" name="">
             <a:extLst xmlns:a="http://schemas.openxmlformats.org/drawingml/2006/main">
               <a:ext uri="{FF2B5EF4-FFF2-40B4-BE49-F238E27FC236}">
-                <a16:creationId xmlns:a16="http://schemas.microsoft.com/office/drawing/2014/main" id="{679302B5-3D0F-4378-9AD9-E135BD19B9B0}"/>
+                <a16:creationId xmlns:a16="http://schemas.microsoft.com/office/drawing/2014/main" id="{940E5CE9-7127-4A9A-AB7D-01807C3E3166}"/>
               </a:ext>
             </a:extLst>
           </p:cNvPr>
@@ -14577,7 +14577,7 @@
     </p:spTree>
     <p:extLst>
       <p:ext uri="{BB962C8B-B14F-4D97-AF65-F5344CB8AC3E}">
-        <p14:creationId xmlns:p14="http://schemas.microsoft.com/office/powerpoint/2010/main" val="952005768"/>
+        <p14:creationId xmlns:p14="http://schemas.microsoft.com/office/powerpoint/2010/main" val="1341781902"/>
       </p:ext>
     </p:extLst>
   </p:cSld>
@@ -14608,7 +14608,7 @@
           <p:cNvPr id="7" name="">
             <a:extLst xmlns:a="http://schemas.openxmlformats.org/drawingml/2006/main">
               <a:ext uri="{FF2B5EF4-FFF2-40B4-BE49-F238E27FC236}">
-                <a16:creationId xmlns:a16="http://schemas.microsoft.com/office/drawing/2014/main" id="{4476DE7A-5DCF-4D24-9E80-D4524A9F719B}"/>
+                <a16:creationId xmlns:a16="http://schemas.microsoft.com/office/drawing/2014/main" id="{F2F4F1FF-4914-458A-B372-EDE00284E6CB}"/>
               </a:ext>
             </a:extLst>
           </p:cNvPr>
@@ -14676,7 +14676,7 @@
           <p:cNvPr id="2" name="">
             <a:extLst xmlns:a="http://schemas.openxmlformats.org/drawingml/2006/main">
               <a:ext uri="{FF2B5EF4-FFF2-40B4-BE49-F238E27FC236}">
-                <a16:creationId xmlns:a16="http://schemas.microsoft.com/office/drawing/2014/main" id="{770B4745-4AFD-4841-98C5-55E4825C1CB1}"/>
+                <a16:creationId xmlns:a16="http://schemas.microsoft.com/office/drawing/2014/main" id="{6DB44CCB-711D-4EAB-9B85-DBFBE94DB939}"/>
               </a:ext>
             </a:extLst>
           </p:cNvPr>
@@ -14744,7 +14744,7 @@
           <p:cNvPr id="3" name="">
             <a:extLst xmlns:a="http://schemas.openxmlformats.org/drawingml/2006/main">
               <a:ext uri="{FF2B5EF4-FFF2-40B4-BE49-F238E27FC236}">
-                <a16:creationId xmlns:a16="http://schemas.microsoft.com/office/drawing/2014/main" id="{2D0BE5A4-5980-47FC-92EA-51B6E04790DF}"/>
+                <a16:creationId xmlns:a16="http://schemas.microsoft.com/office/drawing/2014/main" id="{3F21EF0B-23A1-4ADD-AAF9-03CCA712E3F2}"/>
               </a:ext>
             </a:extLst>
           </p:cNvPr>
@@ -14862,7 +14862,7 @@
           <p:cNvPr id="4" name="">
             <a:extLst xmlns:a="http://schemas.openxmlformats.org/drawingml/2006/main">
               <a:ext uri="{FF2B5EF4-FFF2-40B4-BE49-F238E27FC236}">
-                <a16:creationId xmlns:a16="http://schemas.microsoft.com/office/drawing/2014/main" id="{9F1770F3-F231-4BB2-AE90-0C6CBE44BBEB}"/>
+                <a16:creationId xmlns:a16="http://schemas.microsoft.com/office/drawing/2014/main" id="{586AB690-5565-4AB4-BF47-E056CE9ED995}"/>
               </a:ext>
             </a:extLst>
           </p:cNvPr>
@@ -14988,7 +14988,7 @@
           <p:cNvPr id="5" name="">
             <a:extLst xmlns:a="http://schemas.openxmlformats.org/drawingml/2006/main">
               <a:ext uri="{FF2B5EF4-FFF2-40B4-BE49-F238E27FC236}">
-                <a16:creationId xmlns:a16="http://schemas.microsoft.com/office/drawing/2014/main" id="{26074271-980E-4F5F-A3F4-A7BC9D22C1E2}"/>
+                <a16:creationId xmlns:a16="http://schemas.microsoft.com/office/drawing/2014/main" id="{BBE374A5-568D-445F-8979-4B3228498F74}"/>
               </a:ext>
             </a:extLst>
           </p:cNvPr>
@@ -15056,7 +15056,7 @@
           <p:cNvPr id="6" name="">
             <a:extLst xmlns:a="http://schemas.openxmlformats.org/drawingml/2006/main">
               <a:ext uri="{FF2B5EF4-FFF2-40B4-BE49-F238E27FC236}">
-                <a16:creationId xmlns:a16="http://schemas.microsoft.com/office/drawing/2014/main" id="{C2F88778-0EF8-454B-8417-BC3134957712}"/>
+                <a16:creationId xmlns:a16="http://schemas.microsoft.com/office/drawing/2014/main" id="{122BEBD2-84AE-4979-815E-FB800F9E42F7}"/>
               </a:ext>
             </a:extLst>
           </p:cNvPr>
@@ -15122,7 +15122,7 @@
     </p:spTree>
     <p:extLst>
       <p:ext uri="{BB962C8B-B14F-4D97-AF65-F5344CB8AC3E}">
-        <p14:creationId xmlns:p14="http://schemas.microsoft.com/office/powerpoint/2010/main" val="468466252"/>
+        <p14:creationId xmlns:p14="http://schemas.microsoft.com/office/powerpoint/2010/main" val="1990488933"/>
       </p:ext>
     </p:extLst>
   </p:cSld>
@@ -15153,7 +15153,7 @@
           <p:cNvPr id="13" name="">
             <a:extLst xmlns:a="http://schemas.openxmlformats.org/drawingml/2006/main">
               <a:ext uri="{FF2B5EF4-FFF2-40B4-BE49-F238E27FC236}">
-                <a16:creationId xmlns:a16="http://schemas.microsoft.com/office/drawing/2014/main" id="{801BD70D-8041-4CF0-8845-B2E0F17E087F}"/>
+                <a16:creationId xmlns:a16="http://schemas.microsoft.com/office/drawing/2014/main" id="{7C762333-44EF-4110-8CD4-812B97924F98}"/>
               </a:ext>
             </a:extLst>
           </p:cNvPr>
@@ -15221,7 +15221,7 @@
           <p:cNvPr id="2" name="">
             <a:extLst xmlns:a="http://schemas.openxmlformats.org/drawingml/2006/main">
               <a:ext uri="{FF2B5EF4-FFF2-40B4-BE49-F238E27FC236}">
-                <a16:creationId xmlns:a16="http://schemas.microsoft.com/office/drawing/2014/main" id="{EB45C8CB-930B-49ED-B1F6-DF94E11E27B9}"/>
+                <a16:creationId xmlns:a16="http://schemas.microsoft.com/office/drawing/2014/main" id="{1D71018B-0FE5-40F8-86F6-33BD9AC21E53}"/>
               </a:ext>
             </a:extLst>
           </p:cNvPr>
@@ -15289,7 +15289,7 @@
           <p:cNvPr id="3" name="">
             <a:extLst xmlns:a="http://schemas.openxmlformats.org/drawingml/2006/main">
               <a:ext uri="{FF2B5EF4-FFF2-40B4-BE49-F238E27FC236}">
-                <a16:creationId xmlns:a16="http://schemas.microsoft.com/office/drawing/2014/main" id="{29B3BB39-A7EB-4B70-8873-FA901EFA2C13}"/>
+                <a16:creationId xmlns:a16="http://schemas.microsoft.com/office/drawing/2014/main" id="{9AF443AC-383D-4577-ADB4-2EEC2A364E75}"/>
               </a:ext>
             </a:extLst>
           </p:cNvPr>
@@ -15357,7 +15357,7 @@
           <p:cNvPr id="4" name="">
             <a:extLst xmlns:a="http://schemas.openxmlformats.org/drawingml/2006/main">
               <a:ext uri="{FF2B5EF4-FFF2-40B4-BE49-F238E27FC236}">
-                <a16:creationId xmlns:a16="http://schemas.microsoft.com/office/drawing/2014/main" id="{7D851910-B9EF-4B8C-B788-9662E629588C}"/>
+                <a16:creationId xmlns:a16="http://schemas.microsoft.com/office/drawing/2014/main" id="{B2693FCD-FA32-4322-8CD2-6A72A3CB01CD}"/>
               </a:ext>
             </a:extLst>
           </p:cNvPr>
@@ -15425,7 +15425,7 @@
           <p:cNvPr id="5" name="">
             <a:extLst xmlns:a="http://schemas.openxmlformats.org/drawingml/2006/main">
               <a:ext uri="{FF2B5EF4-FFF2-40B4-BE49-F238E27FC236}">
-                <a16:creationId xmlns:a16="http://schemas.microsoft.com/office/drawing/2014/main" id="{9BE7F48C-1E13-428D-A663-88B400DC3815}"/>
+                <a16:creationId xmlns:a16="http://schemas.microsoft.com/office/drawing/2014/main" id="{BD08709F-9723-4FF1-ABFF-0C569EE53391}"/>
               </a:ext>
             </a:extLst>
           </p:cNvPr>
@@ -15493,7 +15493,7 @@
           <p:cNvPr id="6" name="">
             <a:extLst xmlns:a="http://schemas.openxmlformats.org/drawingml/2006/main">
               <a:ext uri="{FF2B5EF4-FFF2-40B4-BE49-F238E27FC236}">
-                <a16:creationId xmlns:a16="http://schemas.microsoft.com/office/drawing/2014/main" id="{5E5309BB-62FB-4C7A-B5E2-331C47CFBA1C}"/>
+                <a16:creationId xmlns:a16="http://schemas.microsoft.com/office/drawing/2014/main" id="{E6BF30B6-8D54-4A5B-8356-671E510407BF}"/>
               </a:ext>
             </a:extLst>
           </p:cNvPr>
@@ -15561,7 +15561,7 @@
           <p:cNvPr id="7" name="">
             <a:extLst xmlns:a="http://schemas.openxmlformats.org/drawingml/2006/main">
               <a:ext uri="{FF2B5EF4-FFF2-40B4-BE49-F238E27FC236}">
-                <a16:creationId xmlns:a16="http://schemas.microsoft.com/office/drawing/2014/main" id="{48D396BE-84EC-410E-B0CA-A35F4A2551AB}"/>
+                <a16:creationId xmlns:a16="http://schemas.microsoft.com/office/drawing/2014/main" id="{6C8DDA49-8C83-4545-A07B-E93896F83E63}"/>
               </a:ext>
             </a:extLst>
           </p:cNvPr>
@@ -15629,7 +15629,7 @@
           <p:cNvPr id="8" name="">
             <a:extLst xmlns:a="http://schemas.openxmlformats.org/drawingml/2006/main">
               <a:ext uri="{FF2B5EF4-FFF2-40B4-BE49-F238E27FC236}">
-                <a16:creationId xmlns:a16="http://schemas.microsoft.com/office/drawing/2014/main" id="{6185F515-2F12-4D56-A513-ED7A68BC8D66}"/>
+                <a16:creationId xmlns:a16="http://schemas.microsoft.com/office/drawing/2014/main" id="{3D3DCF96-8B26-4455-BFBB-5862CE3138AA}"/>
               </a:ext>
             </a:extLst>
           </p:cNvPr>
@@ -15697,7 +15697,7 @@
           <p:cNvPr id="9" name="">
             <a:extLst xmlns:a="http://schemas.openxmlformats.org/drawingml/2006/main">
               <a:ext uri="{FF2B5EF4-FFF2-40B4-BE49-F238E27FC236}">
-                <a16:creationId xmlns:a16="http://schemas.microsoft.com/office/drawing/2014/main" id="{14C7A619-E4EF-45AD-A0D5-8979501DEB2B}"/>
+                <a16:creationId xmlns:a16="http://schemas.microsoft.com/office/drawing/2014/main" id="{028DF841-0969-4744-A72A-D21F3E9E9F53}"/>
               </a:ext>
             </a:extLst>
           </p:cNvPr>
@@ -15769,7 +15769,7 @@
           <p:cNvPr id="10" name="">
             <a:extLst xmlns:a="http://schemas.openxmlformats.org/drawingml/2006/main">
               <a:ext uri="{FF2B5EF4-FFF2-40B4-BE49-F238E27FC236}">
-                <a16:creationId xmlns:a16="http://schemas.microsoft.com/office/drawing/2014/main" id="{E969498A-0755-40CC-B1A1-4EA3649F1C34}"/>
+                <a16:creationId xmlns:a16="http://schemas.microsoft.com/office/drawing/2014/main" id="{1CA2A11A-0099-42BD-95A8-3B0B503A9677}"/>
               </a:ext>
             </a:extLst>
           </p:cNvPr>
@@ -15837,7 +15837,7 @@
           <p:cNvPr id="11" name="">
             <a:extLst xmlns:a="http://schemas.openxmlformats.org/drawingml/2006/main">
               <a:ext uri="{FF2B5EF4-FFF2-40B4-BE49-F238E27FC236}">
-                <a16:creationId xmlns:a16="http://schemas.microsoft.com/office/drawing/2014/main" id="{23DBB26C-18DA-4ED4-81DF-844A0C09D21B}"/>
+                <a16:creationId xmlns:a16="http://schemas.microsoft.com/office/drawing/2014/main" id="{EB63DF50-ABB9-4429-854A-E2E09752D762}"/>
               </a:ext>
             </a:extLst>
           </p:cNvPr>
@@ -15905,7 +15905,7 @@
           <p:cNvPr id="12" name="">
             <a:extLst xmlns:a="http://schemas.openxmlformats.org/drawingml/2006/main">
               <a:ext uri="{FF2B5EF4-FFF2-40B4-BE49-F238E27FC236}">
-                <a16:creationId xmlns:a16="http://schemas.microsoft.com/office/drawing/2014/main" id="{73EB3023-BE26-4E39-8B1F-FE8B4B835CA9}"/>
+                <a16:creationId xmlns:a16="http://schemas.microsoft.com/office/drawing/2014/main" id="{0CE9F6D3-A719-49AC-9687-41096377B038}"/>
               </a:ext>
             </a:extLst>
           </p:cNvPr>
@@ -15971,7 +15971,7 @@
     </p:spTree>
     <p:extLst>
       <p:ext uri="{BB962C8B-B14F-4D97-AF65-F5344CB8AC3E}">
-        <p14:creationId xmlns:p14="http://schemas.microsoft.com/office/powerpoint/2010/main" val="641817353"/>
+        <p14:creationId xmlns:p14="http://schemas.microsoft.com/office/powerpoint/2010/main" val="1251878118"/>
       </p:ext>
     </p:extLst>
   </p:cSld>
@@ -16002,7 +16002,7 @@
           <p:cNvPr id="11" name="">
             <a:extLst xmlns:a="http://schemas.openxmlformats.org/drawingml/2006/main">
               <a:ext uri="{FF2B5EF4-FFF2-40B4-BE49-F238E27FC236}">
-                <a16:creationId xmlns:a16="http://schemas.microsoft.com/office/drawing/2014/main" id="{4F3D5964-F518-492D-AED9-913CC05BDFD0}"/>
+                <a16:creationId xmlns:a16="http://schemas.microsoft.com/office/drawing/2014/main" id="{8948E35F-09C1-46A0-8586-12F86DE8C49F}"/>
               </a:ext>
             </a:extLst>
           </p:cNvPr>
@@ -16070,7 +16070,7 @@
           <p:cNvPr id="2" name="">
             <a:extLst xmlns:a="http://schemas.openxmlformats.org/drawingml/2006/main">
               <a:ext uri="{FF2B5EF4-FFF2-40B4-BE49-F238E27FC236}">
-                <a16:creationId xmlns:a16="http://schemas.microsoft.com/office/drawing/2014/main" id="{B0F3E42C-9A7A-4EE7-9AD9-94456A5B4FE5}"/>
+                <a16:creationId xmlns:a16="http://schemas.microsoft.com/office/drawing/2014/main" id="{5A6EC31D-E976-4610-BC94-A7F47EA49EA4}"/>
               </a:ext>
             </a:extLst>
           </p:cNvPr>
@@ -16138,7 +16138,7 @@
           <p:cNvPr id="3" name="">
             <a:extLst xmlns:a="http://schemas.openxmlformats.org/drawingml/2006/main">
               <a:ext uri="{FF2B5EF4-FFF2-40B4-BE49-F238E27FC236}">
-                <a16:creationId xmlns:a16="http://schemas.microsoft.com/office/drawing/2014/main" id="{A6E47614-9675-4EEC-9DDD-B66257756D05}"/>
+                <a16:creationId xmlns:a16="http://schemas.microsoft.com/office/drawing/2014/main" id="{C5E73E06-BFF3-4E96-8AF8-4A323CFBB708}"/>
               </a:ext>
             </a:extLst>
           </p:cNvPr>
@@ -16210,7 +16210,7 @@
           <p:cNvPr id="4" name="">
             <a:extLst xmlns:a="http://schemas.openxmlformats.org/drawingml/2006/main">
               <a:ext uri="{FF2B5EF4-FFF2-40B4-BE49-F238E27FC236}">
-                <a16:creationId xmlns:a16="http://schemas.microsoft.com/office/drawing/2014/main" id="{F2FEEB3E-2A85-431A-8A2A-BC1CCD8729DD}"/>
+                <a16:creationId xmlns:a16="http://schemas.microsoft.com/office/drawing/2014/main" id="{697ADB8D-9230-4095-B0BF-7D187EFC08BA}"/>
               </a:ext>
             </a:extLst>
           </p:cNvPr>
@@ -16282,7 +16282,7 @@
           <p:cNvPr id="5" name="">
             <a:extLst xmlns:a="http://schemas.openxmlformats.org/drawingml/2006/main">
               <a:ext uri="{FF2B5EF4-FFF2-40B4-BE49-F238E27FC236}">
-                <a16:creationId xmlns:a16="http://schemas.microsoft.com/office/drawing/2014/main" id="{C873DC1C-BA3E-46A4-AF3C-B5DCF0DE1581}"/>
+                <a16:creationId xmlns:a16="http://schemas.microsoft.com/office/drawing/2014/main" id="{42BA40B1-5650-47B2-883C-19297115E831}"/>
               </a:ext>
             </a:extLst>
           </p:cNvPr>
@@ -16354,7 +16354,7 @@
           <p:cNvPr id="6" name="">
             <a:extLst xmlns:a="http://schemas.openxmlformats.org/drawingml/2006/main">
               <a:ext uri="{FF2B5EF4-FFF2-40B4-BE49-F238E27FC236}">
-                <a16:creationId xmlns:a16="http://schemas.microsoft.com/office/drawing/2014/main" id="{D2E27D21-1363-4C8C-B5C8-9FB3F1EA4318}"/>
+                <a16:creationId xmlns:a16="http://schemas.microsoft.com/office/drawing/2014/main" id="{4BDB35C1-6921-4050-BEF8-5AF76627DAB7}"/>
               </a:ext>
             </a:extLst>
           </p:cNvPr>
@@ -16426,7 +16426,7 @@
           <p:cNvPr id="7" name="">
             <a:extLst xmlns:a="http://schemas.openxmlformats.org/drawingml/2006/main">
               <a:ext uri="{FF2B5EF4-FFF2-40B4-BE49-F238E27FC236}">
-                <a16:creationId xmlns:a16="http://schemas.microsoft.com/office/drawing/2014/main" id="{87AABB75-391E-49F4-BB4B-F48AB27A31B7}"/>
+                <a16:creationId xmlns:a16="http://schemas.microsoft.com/office/drawing/2014/main" id="{BA8672F0-2E14-49D4-837D-57814A4944A5}"/>
               </a:ext>
             </a:extLst>
           </p:cNvPr>
@@ -16498,7 +16498,7 @@
           <p:cNvPr id="8" name="">
             <a:extLst xmlns:a="http://schemas.openxmlformats.org/drawingml/2006/main">
               <a:ext uri="{FF2B5EF4-FFF2-40B4-BE49-F238E27FC236}">
-                <a16:creationId xmlns:a16="http://schemas.microsoft.com/office/drawing/2014/main" id="{4AC37915-E60C-4B3E-AAAD-2569C1B22DCD}"/>
+                <a16:creationId xmlns:a16="http://schemas.microsoft.com/office/drawing/2014/main" id="{8A157102-E588-4898-8A35-936A92F41FE0}"/>
               </a:ext>
             </a:extLst>
           </p:cNvPr>
@@ -16566,7 +16566,7 @@
           <p:cNvPr id="9" name="">
             <a:extLst xmlns:a="http://schemas.openxmlformats.org/drawingml/2006/main">
               <a:ext uri="{FF2B5EF4-FFF2-40B4-BE49-F238E27FC236}">
-                <a16:creationId xmlns:a16="http://schemas.microsoft.com/office/drawing/2014/main" id="{2AE8CED4-F516-457E-BFFF-AC761E5847BB}"/>
+                <a16:creationId xmlns:a16="http://schemas.microsoft.com/office/drawing/2014/main" id="{D4275573-3950-466D-BE1E-9ADB6F102483}"/>
               </a:ext>
             </a:extLst>
           </p:cNvPr>
@@ -16634,7 +16634,7 @@
           <p:cNvPr id="10" name="">
             <a:extLst xmlns:a="http://schemas.openxmlformats.org/drawingml/2006/main">
               <a:ext uri="{FF2B5EF4-FFF2-40B4-BE49-F238E27FC236}">
-                <a16:creationId xmlns:a16="http://schemas.microsoft.com/office/drawing/2014/main" id="{77BD0792-D90E-4CD2-A3A5-70780C681A02}"/>
+                <a16:creationId xmlns:a16="http://schemas.microsoft.com/office/drawing/2014/main" id="{E1C25325-CC85-4F04-82B9-6AB4765EF706}"/>
               </a:ext>
             </a:extLst>
           </p:cNvPr>
@@ -16700,7 +16700,7 @@
     </p:spTree>
     <p:extLst>
       <p:ext uri="{BB962C8B-B14F-4D97-AF65-F5344CB8AC3E}">
-        <p14:creationId xmlns:p14="http://schemas.microsoft.com/office/powerpoint/2010/main" val="1863316132"/>
+        <p14:creationId xmlns:p14="http://schemas.microsoft.com/office/powerpoint/2010/main" val="1096359930"/>
       </p:ext>
     </p:extLst>
   </p:cSld>
@@ -16731,7 +16731,7 @@
           <p:cNvPr id="6" name="">
             <a:extLst xmlns:a="http://schemas.openxmlformats.org/drawingml/2006/main">
               <a:ext uri="{FF2B5EF4-FFF2-40B4-BE49-F238E27FC236}">
-                <a16:creationId xmlns:a16="http://schemas.microsoft.com/office/drawing/2014/main" id="{B0071191-AD90-4D41-B369-83E7EFB89164}"/>
+                <a16:creationId xmlns:a16="http://schemas.microsoft.com/office/drawing/2014/main" id="{98D39E5F-AC02-42C5-A4AF-149D1E38B5A4}"/>
               </a:ext>
             </a:extLst>
           </p:cNvPr>
@@ -16799,7 +16799,7 @@
           <p:cNvPr id="2" name="">
             <a:extLst xmlns:a="http://schemas.openxmlformats.org/drawingml/2006/main">
               <a:ext uri="{FF2B5EF4-FFF2-40B4-BE49-F238E27FC236}">
-                <a16:creationId xmlns:a16="http://schemas.microsoft.com/office/drawing/2014/main" id="{7285E84A-BFB4-4EA9-B75C-5CF5D5584385}"/>
+                <a16:creationId xmlns:a16="http://schemas.microsoft.com/office/drawing/2014/main" id="{C0662635-464D-423B-B9DE-A2303EFA677E}"/>
               </a:ext>
             </a:extLst>
           </p:cNvPr>
@@ -16867,7 +16867,7 @@
           <p:cNvPr id="3" name="">
             <a:extLst xmlns:a="http://schemas.openxmlformats.org/drawingml/2006/main">
               <a:ext uri="{FF2B5EF4-FFF2-40B4-BE49-F238E27FC236}">
-                <a16:creationId xmlns:a16="http://schemas.microsoft.com/office/drawing/2014/main" id="{7BF0AE44-D886-47DA-835F-465839871EA0}"/>
+                <a16:creationId xmlns:a16="http://schemas.microsoft.com/office/drawing/2014/main" id="{2E4BB2FD-5787-4A8C-8908-3449C9F29079}"/>
               </a:ext>
             </a:extLst>
           </p:cNvPr>
@@ -16921,7 +16921,7 @@
           <p:cNvPr id="4" name="">
             <a:extLst xmlns:a="http://schemas.openxmlformats.org/drawingml/2006/main">
               <a:ext uri="{FF2B5EF4-FFF2-40B4-BE49-F238E27FC236}">
-                <a16:creationId xmlns:a16="http://schemas.microsoft.com/office/drawing/2014/main" id="{6AA2E93C-00A8-4109-8BC9-D2AD4DE76DAD}"/>
+                <a16:creationId xmlns:a16="http://schemas.microsoft.com/office/drawing/2014/main" id="{081483D5-F688-44E2-BB73-B265EF9E5094}"/>
               </a:ext>
             </a:extLst>
           </p:cNvPr>
@@ -17132,7 +17132,7 @@
           <p:cNvPr id="5" name="">
             <a:extLst xmlns:a="http://schemas.openxmlformats.org/drawingml/2006/main">
               <a:ext uri="{FF2B5EF4-FFF2-40B4-BE49-F238E27FC236}">
-                <a16:creationId xmlns:a16="http://schemas.microsoft.com/office/drawing/2014/main" id="{F16E927A-AC25-46F9-B266-57D91F82F99C}"/>
+                <a16:creationId xmlns:a16="http://schemas.microsoft.com/office/drawing/2014/main" id="{20189AF9-9368-4D87-B129-7B337DD45630}"/>
               </a:ext>
             </a:extLst>
           </p:cNvPr>
@@ -17198,7 +17198,7 @@
     </p:spTree>
     <p:extLst>
       <p:ext uri="{BB962C8B-B14F-4D97-AF65-F5344CB8AC3E}">
-        <p14:creationId xmlns:p14="http://schemas.microsoft.com/office/powerpoint/2010/main" val="951738083"/>
+        <p14:creationId xmlns:p14="http://schemas.microsoft.com/office/powerpoint/2010/main" val="916753530"/>
       </p:ext>
     </p:extLst>
   </p:cSld>
@@ -17229,7 +17229,7 @@
           <p:cNvPr id="3" name="">
             <a:extLst xmlns:a="http://schemas.openxmlformats.org/drawingml/2006/main">
               <a:ext uri="{FF2B5EF4-FFF2-40B4-BE49-F238E27FC236}">
-                <a16:creationId xmlns:a16="http://schemas.microsoft.com/office/drawing/2014/main" id="{9E575244-5578-4DC4-8DE2-2924C0F58923}"/>
+                <a16:creationId xmlns:a16="http://schemas.microsoft.com/office/drawing/2014/main" id="{B277D589-2B0A-4810-83E2-A687D010D505}"/>
               </a:ext>
             </a:extLst>
           </p:cNvPr>
@@ -17297,7 +17297,7 @@
           <p:cNvPr id="2" name="">
             <a:extLst xmlns:a="http://schemas.openxmlformats.org/drawingml/2006/main">
               <a:ext uri="{FF2B5EF4-FFF2-40B4-BE49-F238E27FC236}">
-                <a16:creationId xmlns:a16="http://schemas.microsoft.com/office/drawing/2014/main" id="{A4FF58BD-E4AC-4293-A63C-6912092C2CF5}"/>
+                <a16:creationId xmlns:a16="http://schemas.microsoft.com/office/drawing/2014/main" id="{104EA609-B1BE-4C00-8417-3012D09BFF5C}"/>
               </a:ext>
             </a:extLst>
           </p:cNvPr>
@@ -17363,7 +17363,7 @@
     </p:spTree>
     <p:extLst>
       <p:ext uri="{BB962C8B-B14F-4D97-AF65-F5344CB8AC3E}">
-        <p14:creationId xmlns:p14="http://schemas.microsoft.com/office/powerpoint/2010/main" val="1592391185"/>
+        <p14:creationId xmlns:p14="http://schemas.microsoft.com/office/powerpoint/2010/main" val="376914370"/>
       </p:ext>
     </p:extLst>
   </p:cSld>

</xml_diff>